<commit_message>
Remove yellow accent bars from slide layouts
Co-Authored-By: Claude Opus 4.6 <noreply@anthropic.com>
</commit_message>
<xml_diff>
--- a/sinusoid_recovery/sinusoid_transformer_design.pptx
+++ b/sinusoid_recovery/sinusoid_transformer_design.pptx
@@ -3153,50 +3153,7 @@
       </p:sp>
       <p:sp>
         <p:nvSpPr>
-          <p:cNvPr id="3" name="Rectangle 2"/>
-          <p:cNvSpPr/>
-          <p:nvPr/>
-        </p:nvSpPr>
-        <p:spPr>
-          <a:xfrm>
-            <a:off x="0" y="0"/>
-            <a:ext cx="365760" cy="6858000"/>
-          </a:xfrm>
-          <a:prstGeom prst="rect">
-            <a:avLst/>
-          </a:prstGeom>
-          <a:solidFill>
-            <a:srgbClr val="F5A623"/>
-          </a:solidFill>
-          <a:ln>
-            <a:noFill/>
-          </a:ln>
-        </p:spPr>
-        <p:style>
-          <a:lnRef idx="1">
-            <a:schemeClr val="accent1"/>
-          </a:lnRef>
-          <a:fillRef idx="3">
-            <a:schemeClr val="accent1"/>
-          </a:fillRef>
-          <a:effectRef idx="2">
-            <a:schemeClr val="accent1"/>
-          </a:effectRef>
-          <a:fontRef idx="minor">
-            <a:schemeClr val="lt1"/>
-          </a:fontRef>
-        </p:style>
-        <p:txBody>
-          <a:bodyPr rtlCol="0" anchor="ctr"/>
-          <a:lstStyle/>
-          <a:p>
-            <a:pPr algn="ctr"/>
-          </a:p>
-        </p:txBody>
-      </p:sp>
-      <p:sp>
-        <p:nvSpPr>
-          <p:cNvPr id="4" name="TextBox 3"/>
+          <p:cNvPr id="3" name="TextBox 2"/>
           <p:cNvSpPr txBox="1"/>
           <p:nvPr/>
         </p:nvSpPr>
@@ -3231,7 +3188,7 @@
       </p:sp>
       <p:sp>
         <p:nvSpPr>
-          <p:cNvPr id="5" name="TextBox 4"/>
+          <p:cNvPr id="4" name="TextBox 3"/>
           <p:cNvSpPr txBox="1"/>
           <p:nvPr/>
         </p:nvSpPr>
@@ -3266,7 +3223,7 @@
       </p:sp>
       <p:sp>
         <p:nvSpPr>
-          <p:cNvPr id="6" name="TextBox 5"/>
+          <p:cNvPr id="5" name="TextBox 4"/>
           <p:cNvSpPr txBox="1"/>
           <p:nvPr/>
         </p:nvSpPr>
@@ -3433,50 +3390,7 @@
       </p:sp>
       <p:sp>
         <p:nvSpPr>
-          <p:cNvPr id="5" name="Rectangle 4"/>
-          <p:cNvSpPr/>
-          <p:nvPr/>
-        </p:nvSpPr>
-        <p:spPr>
-          <a:xfrm>
-            <a:off x="548640" y="1508760"/>
-            <a:ext cx="109728" cy="548640"/>
-          </a:xfrm>
-          <a:prstGeom prst="rect">
-            <a:avLst/>
-          </a:prstGeom>
-          <a:solidFill>
-            <a:srgbClr val="F5A623"/>
-          </a:solidFill>
-          <a:ln>
-            <a:noFill/>
-          </a:ln>
-        </p:spPr>
-        <p:style>
-          <a:lnRef idx="1">
-            <a:schemeClr val="accent1"/>
-          </a:lnRef>
-          <a:fillRef idx="3">
-            <a:schemeClr val="accent1"/>
-          </a:fillRef>
-          <a:effectRef idx="2">
-            <a:schemeClr val="accent1"/>
-          </a:effectRef>
-          <a:fontRef idx="minor">
-            <a:schemeClr val="lt1"/>
-          </a:fontRef>
-        </p:style>
-        <p:txBody>
-          <a:bodyPr rtlCol="0" anchor="ctr"/>
-          <a:lstStyle/>
-          <a:p>
-            <a:pPr algn="ctr"/>
-          </a:p>
-        </p:txBody>
-      </p:sp>
-      <p:sp>
-        <p:nvSpPr>
-          <p:cNvPr id="6" name="TextBox 5"/>
+          <p:cNvPr id="5" name="TextBox 4"/>
           <p:cNvSpPr txBox="1"/>
           <p:nvPr/>
         </p:nvSpPr>
@@ -3511,7 +3425,7 @@
       </p:sp>
       <p:sp>
         <p:nvSpPr>
-          <p:cNvPr id="7" name="TextBox 6"/>
+          <p:cNvPr id="6" name="TextBox 5"/>
           <p:cNvSpPr txBox="1"/>
           <p:nvPr/>
         </p:nvSpPr>
@@ -3558,7 +3472,7 @@
       </p:sp>
       <p:sp>
         <p:nvSpPr>
-          <p:cNvPr id="8" name="TextBox 7"/>
+          <p:cNvPr id="7" name="TextBox 6"/>
           <p:cNvSpPr txBox="1"/>
           <p:nvPr/>
         </p:nvSpPr>
@@ -3593,7 +3507,7 @@
       </p:sp>
       <p:sp>
         <p:nvSpPr>
-          <p:cNvPr id="9" name="TextBox 8"/>
+          <p:cNvPr id="8" name="TextBox 7"/>
           <p:cNvSpPr txBox="1"/>
           <p:nvPr/>
         </p:nvSpPr>
@@ -3796,50 +3710,7 @@
       </p:sp>
       <p:sp>
         <p:nvSpPr>
-          <p:cNvPr id="5" name="Rectangle 4"/>
-          <p:cNvSpPr/>
-          <p:nvPr/>
-        </p:nvSpPr>
-        <p:spPr>
-          <a:xfrm>
-            <a:off x="548640" y="1508760"/>
-            <a:ext cx="109728" cy="548640"/>
-          </a:xfrm>
-          <a:prstGeom prst="rect">
-            <a:avLst/>
-          </a:prstGeom>
-          <a:solidFill>
-            <a:srgbClr val="F5A623"/>
-          </a:solidFill>
-          <a:ln>
-            <a:noFill/>
-          </a:ln>
-        </p:spPr>
-        <p:style>
-          <a:lnRef idx="1">
-            <a:schemeClr val="accent1"/>
-          </a:lnRef>
-          <a:fillRef idx="3">
-            <a:schemeClr val="accent1"/>
-          </a:fillRef>
-          <a:effectRef idx="2">
-            <a:schemeClr val="accent1"/>
-          </a:effectRef>
-          <a:fontRef idx="minor">
-            <a:schemeClr val="lt1"/>
-          </a:fontRef>
-        </p:style>
-        <p:txBody>
-          <a:bodyPr rtlCol="0" anchor="ctr"/>
-          <a:lstStyle/>
-          <a:p>
-            <a:pPr algn="ctr"/>
-          </a:p>
-        </p:txBody>
-      </p:sp>
-      <p:sp>
-        <p:nvSpPr>
-          <p:cNvPr id="6" name="TextBox 5"/>
+          <p:cNvPr id="5" name="TextBox 4"/>
           <p:cNvSpPr txBox="1"/>
           <p:nvPr/>
         </p:nvSpPr>
@@ -3886,7 +3757,7 @@
       </p:sp>
       <p:sp>
         <p:nvSpPr>
-          <p:cNvPr id="7" name="TextBox 6"/>
+          <p:cNvPr id="6" name="TextBox 5"/>
           <p:cNvSpPr txBox="1"/>
           <p:nvPr/>
         </p:nvSpPr>
@@ -3921,7 +3792,7 @@
       </p:sp>
       <p:sp>
         <p:nvSpPr>
-          <p:cNvPr id="8" name="TextBox 7"/>
+          <p:cNvPr id="7" name="TextBox 6"/>
           <p:cNvSpPr txBox="1"/>
           <p:nvPr/>
         </p:nvSpPr>
@@ -4004,7 +3875,7 @@
       </p:sp>
       <p:sp>
         <p:nvSpPr>
-          <p:cNvPr id="9" name="TextBox 8"/>
+          <p:cNvPr id="8" name="TextBox 7"/>
           <p:cNvSpPr txBox="1"/>
           <p:nvPr/>
         </p:nvSpPr>
@@ -4171,50 +4042,7 @@
       </p:sp>
       <p:sp>
         <p:nvSpPr>
-          <p:cNvPr id="5" name="Rectangle 4"/>
-          <p:cNvSpPr/>
-          <p:nvPr/>
-        </p:nvSpPr>
-        <p:spPr>
-          <a:xfrm>
-            <a:off x="548640" y="1508760"/>
-            <a:ext cx="109728" cy="548640"/>
-          </a:xfrm>
-          <a:prstGeom prst="rect">
-            <a:avLst/>
-          </a:prstGeom>
-          <a:solidFill>
-            <a:srgbClr val="F5A623"/>
-          </a:solidFill>
-          <a:ln>
-            <a:noFill/>
-          </a:ln>
-        </p:spPr>
-        <p:style>
-          <a:lnRef idx="1">
-            <a:schemeClr val="accent1"/>
-          </a:lnRef>
-          <a:fillRef idx="3">
-            <a:schemeClr val="accent1"/>
-          </a:fillRef>
-          <a:effectRef idx="2">
-            <a:schemeClr val="accent1"/>
-          </a:effectRef>
-          <a:fontRef idx="minor">
-            <a:schemeClr val="lt1"/>
-          </a:fontRef>
-        </p:style>
-        <p:txBody>
-          <a:bodyPr rtlCol="0" anchor="ctr"/>
-          <a:lstStyle/>
-          <a:p>
-            <a:pPr algn="ctr"/>
-          </a:p>
-        </p:txBody>
-      </p:sp>
-      <p:sp>
-        <p:nvSpPr>
-          <p:cNvPr id="6" name="TextBox 5"/>
+          <p:cNvPr id="5" name="TextBox 4"/>
           <p:cNvSpPr txBox="1"/>
           <p:nvPr/>
         </p:nvSpPr>
@@ -4249,7 +4077,7 @@
       </p:sp>
       <p:sp>
         <p:nvSpPr>
-          <p:cNvPr id="7" name="TextBox 6"/>
+          <p:cNvPr id="6" name="TextBox 5"/>
           <p:cNvSpPr txBox="1"/>
           <p:nvPr/>
         </p:nvSpPr>
@@ -4284,7 +4112,7 @@
       </p:sp>
       <p:sp>
         <p:nvSpPr>
-          <p:cNvPr id="8" name="TextBox 7"/>
+          <p:cNvPr id="7" name="TextBox 6"/>
           <p:cNvSpPr txBox="1"/>
           <p:nvPr/>
         </p:nvSpPr>
@@ -4319,7 +4147,7 @@
       </p:sp>
       <p:sp>
         <p:nvSpPr>
-          <p:cNvPr id="9" name="TextBox 8"/>
+          <p:cNvPr id="8" name="TextBox 7"/>
           <p:cNvSpPr txBox="1"/>
           <p:nvPr/>
         </p:nvSpPr>
@@ -4532,52 +4360,9 @@
           </a:p>
         </p:txBody>
       </p:sp>
-      <p:sp>
-        <p:nvSpPr>
-          <p:cNvPr id="5" name="Rectangle 4"/>
-          <p:cNvSpPr/>
-          <p:nvPr/>
-        </p:nvSpPr>
-        <p:spPr>
-          <a:xfrm>
-            <a:off x="548640" y="1508760"/>
-            <a:ext cx="109728" cy="548640"/>
-          </a:xfrm>
-          <a:prstGeom prst="rect">
-            <a:avLst/>
-          </a:prstGeom>
-          <a:solidFill>
-            <a:srgbClr val="F5A623"/>
-          </a:solidFill>
-          <a:ln>
-            <a:noFill/>
-          </a:ln>
-        </p:spPr>
-        <p:style>
-          <a:lnRef idx="1">
-            <a:schemeClr val="accent1"/>
-          </a:lnRef>
-          <a:fillRef idx="3">
-            <a:schemeClr val="accent1"/>
-          </a:fillRef>
-          <a:effectRef idx="2">
-            <a:schemeClr val="accent1"/>
-          </a:effectRef>
-          <a:fontRef idx="minor">
-            <a:schemeClr val="lt1"/>
-          </a:fontRef>
-        </p:style>
-        <p:txBody>
-          <a:bodyPr rtlCol="0" anchor="ctr"/>
-          <a:lstStyle/>
-          <a:p>
-            <a:pPr algn="ctr"/>
-          </a:p>
-        </p:txBody>
-      </p:sp>
       <p:graphicFrame>
         <p:nvGraphicFramePr>
-          <p:cNvPr id="6" name="Table 5"/>
+          <p:cNvPr id="5" name="Table 4"/>
           <p:cNvGraphicFramePr>
             <a:graphicFrameLocks noGrp="1"/>
           </p:cNvGraphicFramePr>
@@ -5148,7 +4933,7 @@
       </p:graphicFrame>
       <p:sp>
         <p:nvSpPr>
-          <p:cNvPr id="7" name="TextBox 6"/>
+          <p:cNvPr id="6" name="TextBox 5"/>
           <p:cNvSpPr txBox="1"/>
           <p:nvPr/>
         </p:nvSpPr>
@@ -5315,20 +5100,138 @@
       </p:sp>
       <p:sp>
         <p:nvSpPr>
-          <p:cNvPr id="5" name="Rectangle 4"/>
+          <p:cNvPr id="5" name="TextBox 4"/>
+          <p:cNvSpPr txBox="1"/>
+          <p:nvPr/>
+        </p:nvSpPr>
+        <p:spPr>
+          <a:xfrm>
+            <a:off x="777240" y="1737360"/>
+            <a:ext cx="5303520" cy="457200"/>
+          </a:xfrm>
+          <a:prstGeom prst="rect">
+            <a:avLst/>
+          </a:prstGeom>
+          <a:noFill/>
+        </p:spPr>
+        <p:txBody>
+          <a:bodyPr wrap="square" lIns="45720" rIns="45720" tIns="27432" bIns="27432">
+            <a:spAutoFit/>
+          </a:bodyPr>
+          <a:lstStyle/>
+          <a:p>
+            <a:pPr algn="l"/>
+            <a:r>
+              <a:rPr sz="1800" b="1" i="0">
+                <a:solidFill>
+                  <a:srgbClr val="1C7293"/>
+                </a:solidFill>
+                <a:latin typeface="Calibri"/>
+              </a:rPr>
+              <a:t>Recipe</a:t>
+            </a:r>
+          </a:p>
+        </p:txBody>
+      </p:sp>
+      <p:sp>
+        <p:nvSpPr>
+          <p:cNvPr id="6" name="TextBox 5"/>
+          <p:cNvSpPr txBox="1"/>
+          <p:nvPr/>
+        </p:nvSpPr>
+        <p:spPr>
+          <a:xfrm>
+            <a:off x="777240" y="2194560"/>
+            <a:ext cx="5303520" cy="3200400"/>
+          </a:xfrm>
+          <a:prstGeom prst="rect">
+            <a:avLst/>
+          </a:prstGeom>
+          <a:noFill/>
+        </p:spPr>
+        <p:txBody>
+          <a:bodyPr wrap="square" lIns="45720" rIns="45720" tIns="27432" bIns="27432">
+            <a:spAutoFit/>
+          </a:bodyPr>
+          <a:lstStyle/>
+          <a:p>
+            <a:pPr algn="l"/>
+            <a:r>
+              <a:rPr sz="1500" b="0" i="0">
+                <a:solidFill>
+                  <a:srgbClr val="1A1A1A"/>
+                </a:solidFill>
+                <a:latin typeface="Calibri"/>
+              </a:rPr>
+              <a:t>• Loss: MSE</a:t>
+            </a:r>
+          </a:p>
+          <a:p>
+            <a:pPr algn="l"/>
+            <a:r>
+              <a:rPr sz="1500" b="0" i="0">
+                <a:solidFill>
+                  <a:srgbClr val="1A1A1A"/>
+                </a:solidFill>
+                <a:latin typeface="Calibri"/>
+              </a:rPr>
+              <a:t>• Optimizer: AdamW (lr = 1e-3)</a:t>
+            </a:r>
+          </a:p>
+          <a:p>
+            <a:pPr algn="l"/>
+            <a:r>
+              <a:rPr sz="1500" b="0" i="0">
+                <a:solidFill>
+                  <a:srgbClr val="1A1A1A"/>
+                </a:solidFill>
+                <a:latin typeface="Calibri"/>
+              </a:rPr>
+              <a:t>• Batch size: 32</a:t>
+            </a:r>
+          </a:p>
+          <a:p>
+            <a:pPr algn="l"/>
+            <a:r>
+              <a:rPr sz="1500" b="0" i="0">
+                <a:solidFill>
+                  <a:srgbClr val="1A1A1A"/>
+                </a:solidFill>
+                <a:latin typeface="Calibri"/>
+              </a:rPr>
+              <a:t>• 10 000 fresh sinusoids / epoch</a:t>
+            </a:r>
+          </a:p>
+          <a:p>
+            <a:pPr algn="l"/>
+            <a:r>
+              <a:rPr sz="1500" b="0" i="0">
+                <a:solidFill>
+                  <a:srgbClr val="1A1A1A"/>
+                </a:solidFill>
+                <a:latin typeface="Calibri"/>
+              </a:rPr>
+              <a:t>• On-the-fly data generation</a:t>
+            </a:r>
+          </a:p>
+        </p:txBody>
+      </p:sp>
+      <p:sp>
+        <p:nvSpPr>
+          <p:cNvPr id="7" name="Rounded Rectangle 6"/>
           <p:cNvSpPr/>
           <p:nvPr/>
         </p:nvSpPr>
         <p:spPr>
           <a:xfrm>
-            <a:off x="548640" y="1508760"/>
-            <a:ext cx="109728" cy="548640"/>
-          </a:xfrm>
-          <a:prstGeom prst="rect">
+            <a:off x="6400800" y="1737360"/>
+            <a:ext cx="2560320" cy="1371600"/>
+          </a:xfrm>
+          <a:prstGeom prst="roundRect">
             <a:avLst/>
           </a:prstGeom>
           <a:solidFill>
-            <a:srgbClr val="F5A623"/>
+            <a:srgbClr val="065A82"/>
           </a:solidFill>
           <a:ln>
             <a:noFill/>
@@ -5358,14 +5261,14 @@
       </p:sp>
       <p:sp>
         <p:nvSpPr>
-          <p:cNvPr id="6" name="TextBox 5"/>
+          <p:cNvPr id="8" name="TextBox 7"/>
           <p:cNvSpPr txBox="1"/>
           <p:nvPr/>
         </p:nvSpPr>
         <p:spPr>
           <a:xfrm>
-            <a:off x="777240" y="1737360"/>
-            <a:ext cx="5303520" cy="457200"/>
+            <a:off x="6400800" y="1783080"/>
+            <a:ext cx="2560320" cy="365760"/>
           </a:xfrm>
           <a:prstGeom prst="rect">
             <a:avLst/>
@@ -5378,29 +5281,29 @@
           </a:bodyPr>
           <a:lstStyle/>
           <a:p>
-            <a:pPr algn="l"/>
-            <a:r>
-              <a:rPr sz="1800" b="1" i="0">
-                <a:solidFill>
-                  <a:srgbClr val="1C7293"/>
-                </a:solidFill>
-                <a:latin typeface="Calibri"/>
-              </a:rPr>
-              <a:t>Recipe</a:t>
-            </a:r>
-          </a:p>
-        </p:txBody>
-      </p:sp>
-      <p:sp>
-        <p:nvSpPr>
-          <p:cNvPr id="7" name="TextBox 6"/>
+            <a:pPr algn="ctr"/>
+            <a:r>
+              <a:rPr sz="1100" b="0" i="0">
+                <a:solidFill>
+                  <a:srgbClr val="CADCFC"/>
+                </a:solidFill>
+                <a:latin typeface="Calibri"/>
+              </a:rPr>
+              <a:t>Initial MSE</a:t>
+            </a:r>
+          </a:p>
+        </p:txBody>
+      </p:sp>
+      <p:sp>
+        <p:nvSpPr>
+          <p:cNvPr id="9" name="TextBox 8"/>
           <p:cNvSpPr txBox="1"/>
           <p:nvPr/>
         </p:nvSpPr>
         <p:spPr>
           <a:xfrm>
-            <a:off x="777240" y="2194560"/>
-            <a:ext cx="5303520" cy="3200400"/>
+            <a:off x="6400800" y="2103120"/>
+            <a:ext cx="2560320" cy="731520"/>
           </a:xfrm>
           <a:prstGeom prst="rect">
             <a:avLst/>
@@ -5413,76 +5316,28 @@
           </a:bodyPr>
           <a:lstStyle/>
           <a:p>
-            <a:pPr algn="l"/>
-            <a:r>
-              <a:rPr sz="1500" b="0" i="0">
-                <a:solidFill>
-                  <a:srgbClr val="1A1A1A"/>
-                </a:solidFill>
-                <a:latin typeface="Calibri"/>
-              </a:rPr>
-              <a:t>• Loss: MSE</a:t>
-            </a:r>
-          </a:p>
-          <a:p>
-            <a:pPr algn="l"/>
-            <a:r>
-              <a:rPr sz="1500" b="0" i="0">
-                <a:solidFill>
-                  <a:srgbClr val="1A1A1A"/>
-                </a:solidFill>
-                <a:latin typeface="Calibri"/>
-              </a:rPr>
-              <a:t>• Optimizer: AdamW (lr = 1e-3)</a:t>
-            </a:r>
-          </a:p>
-          <a:p>
-            <a:pPr algn="l"/>
-            <a:r>
-              <a:rPr sz="1500" b="0" i="0">
-                <a:solidFill>
-                  <a:srgbClr val="1A1A1A"/>
-                </a:solidFill>
-                <a:latin typeface="Calibri"/>
-              </a:rPr>
-              <a:t>• Batch size: 32</a:t>
-            </a:r>
-          </a:p>
-          <a:p>
-            <a:pPr algn="l"/>
-            <a:r>
-              <a:rPr sz="1500" b="0" i="0">
-                <a:solidFill>
-                  <a:srgbClr val="1A1A1A"/>
-                </a:solidFill>
-                <a:latin typeface="Calibri"/>
-              </a:rPr>
-              <a:t>• 10 000 fresh sinusoids / epoch</a:t>
-            </a:r>
-          </a:p>
-          <a:p>
-            <a:pPr algn="l"/>
-            <a:r>
-              <a:rPr sz="1500" b="0" i="0">
-                <a:solidFill>
-                  <a:srgbClr val="1A1A1A"/>
-                </a:solidFill>
-                <a:latin typeface="Calibri"/>
-              </a:rPr>
-              <a:t>• On-the-fly data generation</a:t>
-            </a:r>
-          </a:p>
-        </p:txBody>
-      </p:sp>
-      <p:sp>
-        <p:nvSpPr>
-          <p:cNvPr id="8" name="Rounded Rectangle 7"/>
+            <a:pPr algn="ctr"/>
+            <a:r>
+              <a:rPr sz="2600" b="1" i="0">
+                <a:solidFill>
+                  <a:srgbClr val="F2F4F8"/>
+                </a:solidFill>
+                <a:latin typeface="Calibri"/>
+              </a:rPr>
+              <a:t>1.40</a:t>
+            </a:r>
+          </a:p>
+        </p:txBody>
+      </p:sp>
+      <p:sp>
+        <p:nvSpPr>
+          <p:cNvPr id="10" name="Rounded Rectangle 9"/>
           <p:cNvSpPr/>
           <p:nvPr/>
         </p:nvSpPr>
         <p:spPr>
           <a:xfrm>
-            <a:off x="6400800" y="1737360"/>
+            <a:off x="9144000" y="1737360"/>
             <a:ext cx="2560320" cy="1371600"/>
           </a:xfrm>
           <a:prstGeom prst="roundRect">
@@ -5519,13 +5374,13 @@
       </p:sp>
       <p:sp>
         <p:nvSpPr>
-          <p:cNvPr id="9" name="TextBox 8"/>
+          <p:cNvPr id="11" name="TextBox 10"/>
           <p:cNvSpPr txBox="1"/>
           <p:nvPr/>
         </p:nvSpPr>
         <p:spPr>
           <a:xfrm>
-            <a:off x="6400800" y="1783080"/>
+            <a:off x="9144000" y="1783080"/>
             <a:ext cx="2560320" cy="365760"/>
           </a:xfrm>
           <a:prstGeom prst="rect">
@@ -5547,20 +5402,20 @@
                 </a:solidFill>
                 <a:latin typeface="Calibri"/>
               </a:rPr>
-              <a:t>Initial MSE</a:t>
-            </a:r>
-          </a:p>
-        </p:txBody>
-      </p:sp>
-      <p:sp>
-        <p:nvSpPr>
-          <p:cNvPr id="10" name="TextBox 9"/>
+              <a:t>Final MSE</a:t>
+            </a:r>
+          </a:p>
+        </p:txBody>
+      </p:sp>
+      <p:sp>
+        <p:nvSpPr>
+          <p:cNvPr id="12" name="TextBox 11"/>
           <p:cNvSpPr txBox="1"/>
           <p:nvPr/>
         </p:nvSpPr>
         <p:spPr>
           <a:xfrm>
-            <a:off x="6400800" y="2103120"/>
+            <a:off x="9144000" y="2103120"/>
             <a:ext cx="2560320" cy="731520"/>
           </a:xfrm>
           <a:prstGeom prst="rect">
@@ -5582,20 +5437,20 @@
                 </a:solidFill>
                 <a:latin typeface="Calibri"/>
               </a:rPr>
-              <a:t>1.40</a:t>
-            </a:r>
-          </a:p>
-        </p:txBody>
-      </p:sp>
-      <p:sp>
-        <p:nvSpPr>
-          <p:cNvPr id="11" name="Rounded Rectangle 10"/>
+              <a:t>0.03</a:t>
+            </a:r>
+          </a:p>
+        </p:txBody>
+      </p:sp>
+      <p:sp>
+        <p:nvSpPr>
+          <p:cNvPr id="13" name="Rounded Rectangle 12"/>
           <p:cNvSpPr/>
           <p:nvPr/>
         </p:nvSpPr>
         <p:spPr>
           <a:xfrm>
-            <a:off x="9144000" y="1737360"/>
+            <a:off x="6400800" y="3291840"/>
             <a:ext cx="2560320" cy="1371600"/>
           </a:xfrm>
           <a:prstGeom prst="roundRect">
@@ -5632,13 +5487,13 @@
       </p:sp>
       <p:sp>
         <p:nvSpPr>
-          <p:cNvPr id="12" name="TextBox 11"/>
+          <p:cNvPr id="14" name="TextBox 13"/>
           <p:cNvSpPr txBox="1"/>
           <p:nvPr/>
         </p:nvSpPr>
         <p:spPr>
           <a:xfrm>
-            <a:off x="9144000" y="1783080"/>
+            <a:off x="6400800" y="3337560"/>
             <a:ext cx="2560320" cy="365760"/>
           </a:xfrm>
           <a:prstGeom prst="rect">
@@ -5660,20 +5515,20 @@
                 </a:solidFill>
                 <a:latin typeface="Calibri"/>
               </a:rPr>
-              <a:t>Final MSE</a:t>
-            </a:r>
-          </a:p>
-        </p:txBody>
-      </p:sp>
-      <p:sp>
-        <p:nvSpPr>
-          <p:cNvPr id="13" name="TextBox 12"/>
+              <a:t>Output SNR</a:t>
+            </a:r>
+          </a:p>
+        </p:txBody>
+      </p:sp>
+      <p:sp>
+        <p:nvSpPr>
+          <p:cNvPr id="15" name="TextBox 14"/>
           <p:cNvSpPr txBox="1"/>
           <p:nvPr/>
         </p:nvSpPr>
         <p:spPr>
           <a:xfrm>
-            <a:off x="9144000" y="2103120"/>
+            <a:off x="6400800" y="3657600"/>
             <a:ext cx="2560320" cy="731520"/>
           </a:xfrm>
           <a:prstGeom prst="rect">
@@ -5695,20 +5550,55 @@
                 </a:solidFill>
                 <a:latin typeface="Calibri"/>
               </a:rPr>
-              <a:t>0.03</a:t>
-            </a:r>
-          </a:p>
-        </p:txBody>
-      </p:sp>
-      <p:sp>
-        <p:nvSpPr>
-          <p:cNvPr id="14" name="Rounded Rectangle 13"/>
+              <a:t>14.8 dB</a:t>
+            </a:r>
+          </a:p>
+        </p:txBody>
+      </p:sp>
+      <p:sp>
+        <p:nvSpPr>
+          <p:cNvPr id="16" name="TextBox 15"/>
+          <p:cNvSpPr txBox="1"/>
+          <p:nvPr/>
+        </p:nvSpPr>
+        <p:spPr>
+          <a:xfrm>
+            <a:off x="6400800" y="4251960"/>
+            <a:ext cx="2560320" cy="365760"/>
+          </a:xfrm>
+          <a:prstGeom prst="rect">
+            <a:avLst/>
+          </a:prstGeom>
+          <a:noFill/>
+        </p:spPr>
+        <p:txBody>
+          <a:bodyPr wrap="square" lIns="45720" rIns="45720" tIns="27432" bIns="27432">
+            <a:spAutoFit/>
+          </a:bodyPr>
+          <a:lstStyle/>
+          <a:p>
+            <a:pPr algn="ctr"/>
+            <a:r>
+              <a:rPr sz="1000" b="0" i="0">
+                <a:solidFill>
+                  <a:srgbClr val="CADCFC"/>
+                </a:solidFill>
+                <a:latin typeface="Calibri"/>
+              </a:rPr>
+              <a:t>matches naive baseline</a:t>
+            </a:r>
+          </a:p>
+        </p:txBody>
+      </p:sp>
+      <p:sp>
+        <p:nvSpPr>
+          <p:cNvPr id="17" name="Rounded Rectangle 16"/>
           <p:cNvSpPr/>
           <p:nvPr/>
         </p:nvSpPr>
         <p:spPr>
           <a:xfrm>
-            <a:off x="6400800" y="3291840"/>
+            <a:off x="9144000" y="3291840"/>
             <a:ext cx="2560320" cy="1371600"/>
           </a:xfrm>
           <a:prstGeom prst="roundRect">
@@ -5745,13 +5635,13 @@
       </p:sp>
       <p:sp>
         <p:nvSpPr>
-          <p:cNvPr id="15" name="TextBox 14"/>
+          <p:cNvPr id="18" name="TextBox 17"/>
           <p:cNvSpPr txBox="1"/>
           <p:nvPr/>
         </p:nvSpPr>
         <p:spPr>
           <a:xfrm>
-            <a:off x="6400800" y="3337560"/>
+            <a:off x="9144000" y="3337560"/>
             <a:ext cx="2560320" cy="365760"/>
           </a:xfrm>
           <a:prstGeom prst="rect">
@@ -5773,20 +5663,20 @@
                 </a:solidFill>
                 <a:latin typeface="Calibri"/>
               </a:rPr>
-              <a:t>Output SNR</a:t>
-            </a:r>
-          </a:p>
-        </p:txBody>
-      </p:sp>
-      <p:sp>
-        <p:nvSpPr>
-          <p:cNvPr id="16" name="TextBox 15"/>
+              <a:t>Parameters</a:t>
+            </a:r>
+          </a:p>
+        </p:txBody>
+      </p:sp>
+      <p:sp>
+        <p:nvSpPr>
+          <p:cNvPr id="19" name="TextBox 18"/>
           <p:cNvSpPr txBox="1"/>
           <p:nvPr/>
         </p:nvSpPr>
         <p:spPr>
           <a:xfrm>
-            <a:off x="6400800" y="3657600"/>
+            <a:off x="9144000" y="3657600"/>
             <a:ext cx="2560320" cy="731520"/>
           </a:xfrm>
           <a:prstGeom prst="rect">
@@ -5808,120 +5698,7 @@
                 </a:solidFill>
                 <a:latin typeface="Calibri"/>
               </a:rPr>
-              <a:t>14.8 dB</a:t>
-            </a:r>
-          </a:p>
-        </p:txBody>
-      </p:sp>
-      <p:sp>
-        <p:nvSpPr>
-          <p:cNvPr id="17" name="TextBox 16"/>
-          <p:cNvSpPr txBox="1"/>
-          <p:nvPr/>
-        </p:nvSpPr>
-        <p:spPr>
-          <a:xfrm>
-            <a:off x="6400800" y="4251960"/>
-            <a:ext cx="2560320" cy="365760"/>
-          </a:xfrm>
-          <a:prstGeom prst="rect">
-            <a:avLst/>
-          </a:prstGeom>
-          <a:noFill/>
-        </p:spPr>
-        <p:txBody>
-          <a:bodyPr wrap="square" lIns="45720" rIns="45720" tIns="27432" bIns="27432">
-            <a:spAutoFit/>
-          </a:bodyPr>
-          <a:lstStyle/>
-          <a:p>
-            <a:pPr algn="ctr"/>
-            <a:r>
-              <a:rPr sz="1000" b="0" i="0">
-                <a:solidFill>
-                  <a:srgbClr val="CADCFC"/>
-                </a:solidFill>
-                <a:latin typeface="Calibri"/>
-              </a:rPr>
-              <a:t>matches naive baseline</a:t>
-            </a:r>
-          </a:p>
-        </p:txBody>
-      </p:sp>
-      <p:sp>
-        <p:nvSpPr>
-          <p:cNvPr id="18" name="Rounded Rectangle 17"/>
-          <p:cNvSpPr/>
-          <p:nvPr/>
-        </p:nvSpPr>
-        <p:spPr>
-          <a:xfrm>
-            <a:off x="9144000" y="3291840"/>
-            <a:ext cx="2560320" cy="1371600"/>
-          </a:xfrm>
-          <a:prstGeom prst="roundRect">
-            <a:avLst/>
-          </a:prstGeom>
-          <a:solidFill>
-            <a:srgbClr val="065A82"/>
-          </a:solidFill>
-          <a:ln>
-            <a:noFill/>
-          </a:ln>
-        </p:spPr>
-        <p:style>
-          <a:lnRef idx="1">
-            <a:schemeClr val="accent1"/>
-          </a:lnRef>
-          <a:fillRef idx="3">
-            <a:schemeClr val="accent1"/>
-          </a:fillRef>
-          <a:effectRef idx="2">
-            <a:schemeClr val="accent1"/>
-          </a:effectRef>
-          <a:fontRef idx="minor">
-            <a:schemeClr val="lt1"/>
-          </a:fontRef>
-        </p:style>
-        <p:txBody>
-          <a:bodyPr rtlCol="0" anchor="ctr"/>
-          <a:lstStyle/>
-          <a:p>
-            <a:pPr algn="ctr"/>
-          </a:p>
-        </p:txBody>
-      </p:sp>
-      <p:sp>
-        <p:nvSpPr>
-          <p:cNvPr id="19" name="TextBox 18"/>
-          <p:cNvSpPr txBox="1"/>
-          <p:nvPr/>
-        </p:nvSpPr>
-        <p:spPr>
-          <a:xfrm>
-            <a:off x="9144000" y="3337560"/>
-            <a:ext cx="2560320" cy="365760"/>
-          </a:xfrm>
-          <a:prstGeom prst="rect">
-            <a:avLst/>
-          </a:prstGeom>
-          <a:noFill/>
-        </p:spPr>
-        <p:txBody>
-          <a:bodyPr wrap="square" lIns="45720" rIns="45720" tIns="27432" bIns="27432">
-            <a:spAutoFit/>
-          </a:bodyPr>
-          <a:lstStyle/>
-          <a:p>
-            <a:pPr algn="ctr"/>
-            <a:r>
-              <a:rPr sz="1100" b="0" i="0">
-                <a:solidFill>
-                  <a:srgbClr val="CADCFC"/>
-                </a:solidFill>
-                <a:latin typeface="Calibri"/>
-              </a:rPr>
-              <a:t>Parameters</a:t>
+              <a:t>29 K</a:t>
             </a:r>
           </a:p>
         </p:txBody>
@@ -5929,41 +5706,6 @@
       <p:sp>
         <p:nvSpPr>
           <p:cNvPr id="20" name="TextBox 19"/>
-          <p:cNvSpPr txBox="1"/>
-          <p:nvPr/>
-        </p:nvSpPr>
-        <p:spPr>
-          <a:xfrm>
-            <a:off x="9144000" y="3657600"/>
-            <a:ext cx="2560320" cy="731520"/>
-          </a:xfrm>
-          <a:prstGeom prst="rect">
-            <a:avLst/>
-          </a:prstGeom>
-          <a:noFill/>
-        </p:spPr>
-        <p:txBody>
-          <a:bodyPr wrap="square" lIns="45720" rIns="45720" tIns="27432" bIns="27432">
-            <a:spAutoFit/>
-          </a:bodyPr>
-          <a:lstStyle/>
-          <a:p>
-            <a:pPr algn="ctr"/>
-            <a:r>
-              <a:rPr sz="2600" b="1" i="0">
-                <a:solidFill>
-                  <a:srgbClr val="F2F4F8"/>
-                </a:solidFill>
-                <a:latin typeface="Calibri"/>
-              </a:rPr>
-              <a:t>29 K</a:t>
-            </a:r>
-          </a:p>
-        </p:txBody>
-      </p:sp>
-      <p:sp>
-        <p:nvSpPr>
-          <p:cNvPr id="21" name="TextBox 20"/>
           <p:cNvSpPr txBox="1"/>
           <p:nvPr/>
         </p:nvSpPr>
@@ -6130,16 +5872,16 @@
       </p:sp>
       <p:sp>
         <p:nvSpPr>
-          <p:cNvPr id="5" name="Rectangle 4"/>
+          <p:cNvPr id="5" name="Oval 4"/>
           <p:cNvSpPr/>
           <p:nvPr/>
         </p:nvSpPr>
         <p:spPr>
           <a:xfrm>
-            <a:off x="548640" y="1508760"/>
-            <a:ext cx="109728" cy="548640"/>
-          </a:xfrm>
-          <a:prstGeom prst="rect">
+            <a:off x="777240" y="1874520"/>
+            <a:ext cx="457200" cy="457200"/>
+          </a:xfrm>
+          <a:prstGeom prst="ellipse">
             <a:avLst/>
           </a:prstGeom>
           <a:solidFill>
@@ -6173,13 +5915,83 @@
       </p:sp>
       <p:sp>
         <p:nvSpPr>
-          <p:cNvPr id="6" name="Oval 5"/>
+          <p:cNvPr id="6" name="TextBox 5"/>
+          <p:cNvSpPr txBox="1"/>
+          <p:nvPr/>
+        </p:nvSpPr>
+        <p:spPr>
+          <a:xfrm>
+            <a:off x="1371600" y="1783080"/>
+            <a:ext cx="10058400" cy="457200"/>
+          </a:xfrm>
+          <a:prstGeom prst="rect">
+            <a:avLst/>
+          </a:prstGeom>
+          <a:noFill/>
+        </p:spPr>
+        <p:txBody>
+          <a:bodyPr wrap="square" lIns="45720" rIns="45720" tIns="27432" bIns="27432">
+            <a:spAutoFit/>
+          </a:bodyPr>
+          <a:lstStyle/>
+          <a:p>
+            <a:pPr algn="l"/>
+            <a:r>
+              <a:rPr sz="1700" b="1" i="0">
+                <a:solidFill>
+                  <a:srgbClr val="065A82"/>
+                </a:solidFill>
+                <a:latin typeface="Calibri"/>
+              </a:rPr>
+              <a:t>Attention heatmaps</a:t>
+            </a:r>
+          </a:p>
+        </p:txBody>
+      </p:sp>
+      <p:sp>
+        <p:nvSpPr>
+          <p:cNvPr id="7" name="TextBox 6"/>
+          <p:cNvSpPr txBox="1"/>
+          <p:nvPr/>
+        </p:nvSpPr>
+        <p:spPr>
+          <a:xfrm>
+            <a:off x="1371600" y="2240280"/>
+            <a:ext cx="10058400" cy="548640"/>
+          </a:xfrm>
+          <a:prstGeom prst="rect">
+            <a:avLst/>
+          </a:prstGeom>
+          <a:noFill/>
+        </p:spPr>
+        <p:txBody>
+          <a:bodyPr wrap="square" lIns="45720" rIns="45720" tIns="27432" bIns="27432">
+            <a:spAutoFit/>
+          </a:bodyPr>
+          <a:lstStyle/>
+          <a:p>
+            <a:pPr algn="l"/>
+            <a:r>
+              <a:rPr sz="1400" b="0" i="0">
+                <a:solidFill>
+                  <a:srgbClr val="1A1A1A"/>
+                </a:solidFill>
+                <a:latin typeface="Calibri"/>
+              </a:rPr>
+              <a:t>Peaks at lag 1 and lag 2 — matches AR(2) tap structure</a:t>
+            </a:r>
+          </a:p>
+        </p:txBody>
+      </p:sp>
+      <p:sp>
+        <p:nvSpPr>
+          <p:cNvPr id="8" name="Oval 7"/>
           <p:cNvSpPr/>
           <p:nvPr/>
         </p:nvSpPr>
         <p:spPr>
           <a:xfrm>
-            <a:off x="777240" y="1874520"/>
+            <a:off x="777240" y="2971800"/>
             <a:ext cx="457200" cy="457200"/>
           </a:xfrm>
           <a:prstGeom prst="ellipse">
@@ -6216,13 +6028,13 @@
       </p:sp>
       <p:sp>
         <p:nvSpPr>
-          <p:cNvPr id="7" name="TextBox 6"/>
+          <p:cNvPr id="9" name="TextBox 8"/>
           <p:cNvSpPr txBox="1"/>
           <p:nvPr/>
         </p:nvSpPr>
         <p:spPr>
           <a:xfrm>
-            <a:off x="1371600" y="1783080"/>
+            <a:off x="1371600" y="2880360"/>
             <a:ext cx="10058400" cy="457200"/>
           </a:xfrm>
           <a:prstGeom prst="rect">
@@ -6244,20 +6056,20 @@
                 </a:solidFill>
                 <a:latin typeface="Calibri"/>
               </a:rPr>
-              <a:t>Attention heatmaps</a:t>
-            </a:r>
-          </a:p>
-        </p:txBody>
-      </p:sp>
-      <p:sp>
-        <p:nvSpPr>
-          <p:cNvPr id="8" name="TextBox 7"/>
+              <a:t>Attention-vs-lag profile</a:t>
+            </a:r>
+          </a:p>
+        </p:txBody>
+      </p:sp>
+      <p:sp>
+        <p:nvSpPr>
+          <p:cNvPr id="10" name="TextBox 9"/>
           <p:cNvSpPr txBox="1"/>
           <p:nvPr/>
         </p:nvSpPr>
         <p:spPr>
           <a:xfrm>
-            <a:off x="1371600" y="2240280"/>
+            <a:off x="1371600" y="3337560"/>
             <a:ext cx="10058400" cy="548640"/>
           </a:xfrm>
           <a:prstGeom prst="rect">
@@ -6279,20 +6091,20 @@
                 </a:solidFill>
                 <a:latin typeface="Calibri"/>
               </a:rPr>
-              <a:t>Peaks at lag 1 and lag 2 — matches AR(2) tap structure</a:t>
-            </a:r>
-          </a:p>
-        </p:txBody>
-      </p:sp>
-      <p:sp>
-        <p:nvSpPr>
-          <p:cNvPr id="9" name="Oval 8"/>
+              <a:t>Bar heights track theoretical  2 cos(ω₀)  weights</a:t>
+            </a:r>
+          </a:p>
+        </p:txBody>
+      </p:sp>
+      <p:sp>
+        <p:nvSpPr>
+          <p:cNvPr id="11" name="Oval 10"/>
           <p:cNvSpPr/>
           <p:nvPr/>
         </p:nvSpPr>
         <p:spPr>
           <a:xfrm>
-            <a:off x="777240" y="2971800"/>
+            <a:off x="777240" y="4069080"/>
             <a:ext cx="457200" cy="457200"/>
           </a:xfrm>
           <a:prstGeom prst="ellipse">
@@ -6329,13 +6141,13 @@
       </p:sp>
       <p:sp>
         <p:nvSpPr>
-          <p:cNvPr id="10" name="TextBox 9"/>
+          <p:cNvPr id="12" name="TextBox 11"/>
           <p:cNvSpPr txBox="1"/>
           <p:nvPr/>
         </p:nvSpPr>
         <p:spPr>
           <a:xfrm>
-            <a:off x="1371600" y="2880360"/>
+            <a:off x="1371600" y="3977640"/>
             <a:ext cx="10058400" cy="457200"/>
           </a:xfrm>
           <a:prstGeom prst="rect">
@@ -6357,20 +6169,20 @@
                 </a:solidFill>
                 <a:latin typeface="Calibri"/>
               </a:rPr>
-              <a:t>Attention-vs-lag profile</a:t>
-            </a:r>
-          </a:p>
-        </p:txBody>
-      </p:sp>
-      <p:sp>
-        <p:nvSpPr>
-          <p:cNvPr id="11" name="TextBox 10"/>
+              <a:t>FFT comparison</a:t>
+            </a:r>
+          </a:p>
+        </p:txBody>
+      </p:sp>
+      <p:sp>
+        <p:nvSpPr>
+          <p:cNvPr id="13" name="TextBox 12"/>
           <p:cNvSpPr txBox="1"/>
           <p:nvPr/>
         </p:nvSpPr>
         <p:spPr>
           <a:xfrm>
-            <a:off x="1371600" y="3337560"/>
+            <a:off x="1371600" y="4434840"/>
             <a:ext cx="10058400" cy="548640"/>
           </a:xfrm>
           <a:prstGeom prst="rect">
@@ -6392,20 +6204,20 @@
                 </a:solidFill>
                 <a:latin typeface="Calibri"/>
               </a:rPr>
-              <a:t>Bar heights track theoretical  2 cos(ω₀)  weights</a:t>
-            </a:r>
-          </a:p>
-        </p:txBody>
-      </p:sp>
-      <p:sp>
-        <p:nvSpPr>
-          <p:cNvPr id="12" name="Oval 11"/>
+              <a:t>Output spectrum concentrates at true frequency, noise suppressed</a:t>
+            </a:r>
+          </a:p>
+        </p:txBody>
+      </p:sp>
+      <p:sp>
+        <p:nvSpPr>
+          <p:cNvPr id="14" name="Oval 13"/>
           <p:cNvSpPr/>
           <p:nvPr/>
         </p:nvSpPr>
         <p:spPr>
           <a:xfrm>
-            <a:off x="777240" y="4069080"/>
+            <a:off x="777240" y="5166360"/>
             <a:ext cx="457200" cy="457200"/>
           </a:xfrm>
           <a:prstGeom prst="ellipse">
@@ -6442,13 +6254,13 @@
       </p:sp>
       <p:sp>
         <p:nvSpPr>
-          <p:cNvPr id="13" name="TextBox 12"/>
+          <p:cNvPr id="15" name="TextBox 14"/>
           <p:cNvSpPr txBox="1"/>
           <p:nvPr/>
         </p:nvSpPr>
         <p:spPr>
           <a:xfrm>
-            <a:off x="1371600" y="3977640"/>
+            <a:off x="1371600" y="5074920"/>
             <a:ext cx="10058400" cy="457200"/>
           </a:xfrm>
           <a:prstGeom prst="rect">
@@ -6470,127 +6282,14 @@
                 </a:solidFill>
                 <a:latin typeface="Calibri"/>
               </a:rPr>
-              <a:t>FFT comparison</a:t>
-            </a:r>
-          </a:p>
-        </p:txBody>
-      </p:sp>
-      <p:sp>
-        <p:nvSpPr>
-          <p:cNvPr id="14" name="TextBox 13"/>
-          <p:cNvSpPr txBox="1"/>
-          <p:nvPr/>
-        </p:nvSpPr>
-        <p:spPr>
-          <a:xfrm>
-            <a:off x="1371600" y="4434840"/>
-            <a:ext cx="10058400" cy="548640"/>
-          </a:xfrm>
-          <a:prstGeom prst="rect">
-            <a:avLst/>
-          </a:prstGeom>
-          <a:noFill/>
-        </p:spPr>
-        <p:txBody>
-          <a:bodyPr wrap="square" lIns="45720" rIns="45720" tIns="27432" bIns="27432">
-            <a:spAutoFit/>
-          </a:bodyPr>
-          <a:lstStyle/>
-          <a:p>
-            <a:pPr algn="l"/>
-            <a:r>
-              <a:rPr sz="1400" b="0" i="0">
-                <a:solidFill>
-                  <a:srgbClr val="1A1A1A"/>
-                </a:solidFill>
-                <a:latin typeface="Calibri"/>
-              </a:rPr>
-              <a:t>Output spectrum concentrates at true frequency, noise suppressed</a:t>
-            </a:r>
-          </a:p>
-        </p:txBody>
-      </p:sp>
-      <p:sp>
-        <p:nvSpPr>
-          <p:cNvPr id="15" name="Oval 14"/>
-          <p:cNvSpPr/>
-          <p:nvPr/>
-        </p:nvSpPr>
-        <p:spPr>
-          <a:xfrm>
-            <a:off x="777240" y="5166360"/>
-            <a:ext cx="457200" cy="457200"/>
-          </a:xfrm>
-          <a:prstGeom prst="ellipse">
-            <a:avLst/>
-          </a:prstGeom>
-          <a:solidFill>
-            <a:srgbClr val="F5A623"/>
-          </a:solidFill>
-          <a:ln>
-            <a:noFill/>
-          </a:ln>
-        </p:spPr>
-        <p:style>
-          <a:lnRef idx="1">
-            <a:schemeClr val="accent1"/>
-          </a:lnRef>
-          <a:fillRef idx="3">
-            <a:schemeClr val="accent1"/>
-          </a:fillRef>
-          <a:effectRef idx="2">
-            <a:schemeClr val="accent1"/>
-          </a:effectRef>
-          <a:fontRef idx="minor">
-            <a:schemeClr val="lt1"/>
-          </a:fontRef>
-        </p:style>
-        <p:txBody>
-          <a:bodyPr rtlCol="0" anchor="ctr"/>
-          <a:lstStyle/>
-          <a:p>
-            <a:pPr algn="ctr"/>
+              <a:t>Autoregressive generation</a:t>
+            </a:r>
           </a:p>
         </p:txBody>
       </p:sp>
       <p:sp>
         <p:nvSpPr>
           <p:cNvPr id="16" name="TextBox 15"/>
-          <p:cNvSpPr txBox="1"/>
-          <p:nvPr/>
-        </p:nvSpPr>
-        <p:spPr>
-          <a:xfrm>
-            <a:off x="1371600" y="5074920"/>
-            <a:ext cx="10058400" cy="457200"/>
-          </a:xfrm>
-          <a:prstGeom prst="rect">
-            <a:avLst/>
-          </a:prstGeom>
-          <a:noFill/>
-        </p:spPr>
-        <p:txBody>
-          <a:bodyPr wrap="square" lIns="45720" rIns="45720" tIns="27432" bIns="27432">
-            <a:spAutoFit/>
-          </a:bodyPr>
-          <a:lstStyle/>
-          <a:p>
-            <a:pPr algn="l"/>
-            <a:r>
-              <a:rPr sz="1700" b="1" i="0">
-                <a:solidFill>
-                  <a:srgbClr val="065A82"/>
-                </a:solidFill>
-                <a:latin typeface="Calibri"/>
-              </a:rPr>
-              <a:t>Autoregressive generation</a:t>
-            </a:r>
-          </a:p>
-        </p:txBody>
-      </p:sp>
-      <p:sp>
-        <p:nvSpPr>
-          <p:cNvPr id="17" name="TextBox 16"/>
           <p:cNvSpPr txBox="1"/>
           <p:nvPr/>
         </p:nvSpPr>
@@ -6755,52 +6454,9 @@
           </a:p>
         </p:txBody>
       </p:sp>
-      <p:sp>
-        <p:nvSpPr>
-          <p:cNvPr id="5" name="Rectangle 4"/>
-          <p:cNvSpPr/>
-          <p:nvPr/>
-        </p:nvSpPr>
-        <p:spPr>
-          <a:xfrm>
-            <a:off x="548640" y="1508760"/>
-            <a:ext cx="109728" cy="548640"/>
-          </a:xfrm>
-          <a:prstGeom prst="rect">
-            <a:avLst/>
-          </a:prstGeom>
-          <a:solidFill>
-            <a:srgbClr val="F5A623"/>
-          </a:solidFill>
-          <a:ln>
-            <a:noFill/>
-          </a:ln>
-        </p:spPr>
-        <p:style>
-          <a:lnRef idx="1">
-            <a:schemeClr val="accent1"/>
-          </a:lnRef>
-          <a:fillRef idx="3">
-            <a:schemeClr val="accent1"/>
-          </a:fillRef>
-          <a:effectRef idx="2">
-            <a:schemeClr val="accent1"/>
-          </a:effectRef>
-          <a:fontRef idx="minor">
-            <a:schemeClr val="lt1"/>
-          </a:fontRef>
-        </p:style>
-        <p:txBody>
-          <a:bodyPr rtlCol="0" anchor="ctr"/>
-          <a:lstStyle/>
-          <a:p>
-            <a:pPr algn="ctr"/>
-          </a:p>
-        </p:txBody>
-      </p:sp>
       <p:graphicFrame>
         <p:nvGraphicFramePr>
-          <p:cNvPr id="6" name="Table 5"/>
+          <p:cNvPr id="5" name="Table 4"/>
           <p:cNvGraphicFramePr>
             <a:graphicFrameLocks noGrp="1"/>
           </p:cNvGraphicFramePr>
@@ -7613,7 +7269,7 @@
       </p:graphicFrame>
       <p:sp>
         <p:nvSpPr>
-          <p:cNvPr id="7" name="TextBox 6"/>
+          <p:cNvPr id="6" name="TextBox 5"/>
           <p:cNvSpPr txBox="1"/>
           <p:nvPr/>
         </p:nvSpPr>
@@ -7778,52 +7434,9 @@
           </a:p>
         </p:txBody>
       </p:sp>
-      <p:sp>
-        <p:nvSpPr>
-          <p:cNvPr id="5" name="Rectangle 4"/>
-          <p:cNvSpPr/>
-          <p:nvPr/>
-        </p:nvSpPr>
-        <p:spPr>
-          <a:xfrm>
-            <a:off x="548640" y="1508760"/>
-            <a:ext cx="109728" cy="548640"/>
-          </a:xfrm>
-          <a:prstGeom prst="rect">
-            <a:avLst/>
-          </a:prstGeom>
-          <a:solidFill>
-            <a:srgbClr val="F5A623"/>
-          </a:solidFill>
-          <a:ln>
-            <a:noFill/>
-          </a:ln>
-        </p:spPr>
-        <p:style>
-          <a:lnRef idx="1">
-            <a:schemeClr val="accent1"/>
-          </a:lnRef>
-          <a:fillRef idx="3">
-            <a:schemeClr val="accent1"/>
-          </a:fillRef>
-          <a:effectRef idx="2">
-            <a:schemeClr val="accent1"/>
-          </a:effectRef>
-          <a:fontRef idx="minor">
-            <a:schemeClr val="lt1"/>
-          </a:fontRef>
-        </p:style>
-        <p:txBody>
-          <a:bodyPr rtlCol="0" anchor="ctr"/>
-          <a:lstStyle/>
-          <a:p>
-            <a:pPr algn="ctr"/>
-          </a:p>
-        </p:txBody>
-      </p:sp>
       <p:graphicFrame>
         <p:nvGraphicFramePr>
-          <p:cNvPr id="6" name="Table 5"/>
+          <p:cNvPr id="5" name="Table 4"/>
           <p:cNvGraphicFramePr>
             <a:graphicFrameLocks noGrp="1"/>
           </p:cNvGraphicFramePr>
@@ -8211,7 +7824,7 @@
       </p:graphicFrame>
       <p:sp>
         <p:nvSpPr>
-          <p:cNvPr id="7" name="TextBox 6"/>
+          <p:cNvPr id="6" name="TextBox 5"/>
           <p:cNvSpPr txBox="1"/>
           <p:nvPr/>
         </p:nvSpPr>
@@ -8246,7 +7859,7 @@
       </p:sp>
       <p:sp>
         <p:nvSpPr>
-          <p:cNvPr id="8" name="TextBox 7"/>
+          <p:cNvPr id="7" name="TextBox 6"/>
           <p:cNvSpPr txBox="1"/>
           <p:nvPr/>
         </p:nvSpPr>
@@ -8461,50 +8074,7 @@
       </p:sp>
       <p:sp>
         <p:nvSpPr>
-          <p:cNvPr id="5" name="Rectangle 4"/>
-          <p:cNvSpPr/>
-          <p:nvPr/>
-        </p:nvSpPr>
-        <p:spPr>
-          <a:xfrm>
-            <a:off x="548640" y="1508760"/>
-            <a:ext cx="109728" cy="548640"/>
-          </a:xfrm>
-          <a:prstGeom prst="rect">
-            <a:avLst/>
-          </a:prstGeom>
-          <a:solidFill>
-            <a:srgbClr val="F5A623"/>
-          </a:solidFill>
-          <a:ln>
-            <a:noFill/>
-          </a:ln>
-        </p:spPr>
-        <p:style>
-          <a:lnRef idx="1">
-            <a:schemeClr val="accent1"/>
-          </a:lnRef>
-          <a:fillRef idx="3">
-            <a:schemeClr val="accent1"/>
-          </a:fillRef>
-          <a:effectRef idx="2">
-            <a:schemeClr val="accent1"/>
-          </a:effectRef>
-          <a:fontRef idx="minor">
-            <a:schemeClr val="lt1"/>
-          </a:fontRef>
-        </p:style>
-        <p:txBody>
-          <a:bodyPr rtlCol="0" anchor="ctr"/>
-          <a:lstStyle/>
-          <a:p>
-            <a:pPr algn="ctr"/>
-          </a:p>
-        </p:txBody>
-      </p:sp>
-      <p:sp>
-        <p:nvSpPr>
-          <p:cNvPr id="6" name="TextBox 5"/>
+          <p:cNvPr id="5" name="TextBox 4"/>
           <p:cNvSpPr txBox="1"/>
           <p:nvPr/>
         </p:nvSpPr>
@@ -8539,7 +8109,7 @@
       </p:sp>
       <p:sp>
         <p:nvSpPr>
-          <p:cNvPr id="7" name="TextBox 6"/>
+          <p:cNvPr id="6" name="TextBox 5"/>
           <p:cNvSpPr txBox="1"/>
           <p:nvPr/>
         </p:nvSpPr>
@@ -8574,7 +8144,7 @@
       </p:sp>
       <p:graphicFrame>
         <p:nvGraphicFramePr>
-          <p:cNvPr id="8" name="Table 7"/>
+          <p:cNvPr id="7" name="Table 6"/>
           <p:cNvGraphicFramePr>
             <a:graphicFrameLocks noGrp="1"/>
           </p:cNvGraphicFramePr>
@@ -8872,7 +8442,7 @@
       </p:graphicFrame>
       <p:sp>
         <p:nvSpPr>
-          <p:cNvPr id="9" name="TextBox 8"/>
+          <p:cNvPr id="8" name="TextBox 7"/>
           <p:cNvSpPr txBox="1"/>
           <p:nvPr/>
         </p:nvSpPr>
@@ -8907,7 +8477,7 @@
       </p:sp>
       <p:graphicFrame>
         <p:nvGraphicFramePr>
-          <p:cNvPr id="10" name="Table 9"/>
+          <p:cNvPr id="9" name="Table 8"/>
           <p:cNvGraphicFramePr>
             <a:graphicFrameLocks noGrp="1"/>
           </p:cNvGraphicFramePr>
@@ -9295,7 +8865,7 @@
       </p:graphicFrame>
       <p:sp>
         <p:nvSpPr>
-          <p:cNvPr id="11" name="TextBox 10"/>
+          <p:cNvPr id="10" name="TextBox 9"/>
           <p:cNvSpPr txBox="1"/>
           <p:nvPr/>
         </p:nvSpPr>
@@ -9462,50 +9032,7 @@
       </p:sp>
       <p:sp>
         <p:nvSpPr>
-          <p:cNvPr id="5" name="Rectangle 4"/>
-          <p:cNvSpPr/>
-          <p:nvPr/>
-        </p:nvSpPr>
-        <p:spPr>
-          <a:xfrm>
-            <a:off x="548640" y="1508760"/>
-            <a:ext cx="109728" cy="548640"/>
-          </a:xfrm>
-          <a:prstGeom prst="rect">
-            <a:avLst/>
-          </a:prstGeom>
-          <a:solidFill>
-            <a:srgbClr val="F5A623"/>
-          </a:solidFill>
-          <a:ln>
-            <a:noFill/>
-          </a:ln>
-        </p:spPr>
-        <p:style>
-          <a:lnRef idx="1">
-            <a:schemeClr val="accent1"/>
-          </a:lnRef>
-          <a:fillRef idx="3">
-            <a:schemeClr val="accent1"/>
-          </a:fillRef>
-          <a:effectRef idx="2">
-            <a:schemeClr val="accent1"/>
-          </a:effectRef>
-          <a:fontRef idx="minor">
-            <a:schemeClr val="lt1"/>
-          </a:fontRef>
-        </p:style>
-        <p:txBody>
-          <a:bodyPr rtlCol="0" anchor="ctr"/>
-          <a:lstStyle/>
-          <a:p>
-            <a:pPr algn="ctr"/>
-          </a:p>
-        </p:txBody>
-      </p:sp>
-      <p:sp>
-        <p:nvSpPr>
-          <p:cNvPr id="6" name="TextBox 5"/>
+          <p:cNvPr id="5" name="TextBox 4"/>
           <p:cNvSpPr txBox="1"/>
           <p:nvPr/>
         </p:nvSpPr>
@@ -9540,7 +9067,7 @@
       </p:sp>
       <p:sp>
         <p:nvSpPr>
-          <p:cNvPr id="7" name="TextBox 6"/>
+          <p:cNvPr id="6" name="TextBox 5"/>
           <p:cNvSpPr txBox="1"/>
           <p:nvPr/>
         </p:nvSpPr>
@@ -9575,7 +9102,7 @@
       </p:sp>
       <p:sp>
         <p:nvSpPr>
-          <p:cNvPr id="8" name="TextBox 7"/>
+          <p:cNvPr id="7" name="TextBox 6"/>
           <p:cNvSpPr txBox="1"/>
           <p:nvPr/>
         </p:nvSpPr>
@@ -9658,7 +9185,7 @@
       </p:sp>
       <p:sp>
         <p:nvSpPr>
-          <p:cNvPr id="9" name="TextBox 8"/>
+          <p:cNvPr id="8" name="TextBox 7"/>
           <p:cNvSpPr txBox="1"/>
           <p:nvPr/>
         </p:nvSpPr>
@@ -9693,7 +9220,7 @@
       </p:sp>
       <p:sp>
         <p:nvSpPr>
-          <p:cNvPr id="10" name="TextBox 9"/>
+          <p:cNvPr id="9" name="TextBox 8"/>
           <p:cNvSpPr txBox="1"/>
           <p:nvPr/>
         </p:nvSpPr>
@@ -9884,50 +9411,7 @@
       </p:sp>
       <p:sp>
         <p:nvSpPr>
-          <p:cNvPr id="5" name="Rectangle 4"/>
-          <p:cNvSpPr/>
-          <p:nvPr/>
-        </p:nvSpPr>
-        <p:spPr>
-          <a:xfrm>
-            <a:off x="548640" y="1508760"/>
-            <a:ext cx="109728" cy="548640"/>
-          </a:xfrm>
-          <a:prstGeom prst="rect">
-            <a:avLst/>
-          </a:prstGeom>
-          <a:solidFill>
-            <a:srgbClr val="F5A623"/>
-          </a:solidFill>
-          <a:ln>
-            <a:noFill/>
-          </a:ln>
-        </p:spPr>
-        <p:style>
-          <a:lnRef idx="1">
-            <a:schemeClr val="accent1"/>
-          </a:lnRef>
-          <a:fillRef idx="3">
-            <a:schemeClr val="accent1"/>
-          </a:fillRef>
-          <a:effectRef idx="2">
-            <a:schemeClr val="accent1"/>
-          </a:effectRef>
-          <a:fontRef idx="minor">
-            <a:schemeClr val="lt1"/>
-          </a:fontRef>
-        </p:style>
-        <p:txBody>
-          <a:bodyPr rtlCol="0" anchor="ctr"/>
-          <a:lstStyle/>
-          <a:p>
-            <a:pPr algn="ctr"/>
-          </a:p>
-        </p:txBody>
-      </p:sp>
-      <p:sp>
-        <p:nvSpPr>
-          <p:cNvPr id="6" name="TextBox 5"/>
+          <p:cNvPr id="5" name="TextBox 4"/>
           <p:cNvSpPr txBox="1"/>
           <p:nvPr/>
         </p:nvSpPr>
@@ -9962,7 +9446,7 @@
       </p:sp>
       <p:sp>
         <p:nvSpPr>
-          <p:cNvPr id="7" name="TextBox 6"/>
+          <p:cNvPr id="6" name="TextBox 5"/>
           <p:cNvSpPr txBox="1"/>
           <p:nvPr/>
         </p:nvSpPr>
@@ -10033,7 +9517,7 @@
       </p:sp>
       <p:sp>
         <p:nvSpPr>
-          <p:cNvPr id="8" name="TextBox 7"/>
+          <p:cNvPr id="7" name="TextBox 6"/>
           <p:cNvSpPr txBox="1"/>
           <p:nvPr/>
         </p:nvSpPr>
@@ -10068,7 +9552,7 @@
       </p:sp>
       <p:sp>
         <p:nvSpPr>
-          <p:cNvPr id="9" name="TextBox 8"/>
+          <p:cNvPr id="8" name="TextBox 7"/>
           <p:cNvSpPr txBox="1"/>
           <p:nvPr/>
         </p:nvSpPr>
@@ -10139,7 +9623,7 @@
       </p:sp>
       <p:sp>
         <p:nvSpPr>
-          <p:cNvPr id="10" name="TextBox 9"/>
+          <p:cNvPr id="9" name="TextBox 8"/>
           <p:cNvSpPr txBox="1"/>
           <p:nvPr/>
         </p:nvSpPr>
@@ -10236,20 +9720,90 @@
       </p:sp>
       <p:sp>
         <p:nvSpPr>
-          <p:cNvPr id="3" name="Rectangle 2"/>
+          <p:cNvPr id="3" name="TextBox 2"/>
+          <p:cNvSpPr txBox="1"/>
+          <p:nvPr/>
+        </p:nvSpPr>
+        <p:spPr>
+          <a:xfrm>
+            <a:off x="914400" y="731520"/>
+            <a:ext cx="10515600" cy="914400"/>
+          </a:xfrm>
+          <a:prstGeom prst="rect">
+            <a:avLst/>
+          </a:prstGeom>
+          <a:noFill/>
+        </p:spPr>
+        <p:txBody>
+          <a:bodyPr wrap="square" lIns="45720" rIns="45720" tIns="27432" bIns="27432">
+            <a:spAutoFit/>
+          </a:bodyPr>
+          <a:lstStyle/>
+          <a:p>
+            <a:pPr algn="l"/>
+            <a:r>
+              <a:rPr sz="3800" b="1" i="0">
+                <a:solidFill>
+                  <a:srgbClr val="F2F4F8"/>
+                </a:solidFill>
+                <a:latin typeface="Calibri"/>
+              </a:rPr>
+              <a:t>Key Takeaway</a:t>
+            </a:r>
+          </a:p>
+        </p:txBody>
+      </p:sp>
+      <p:sp>
+        <p:nvSpPr>
+          <p:cNvPr id="4" name="TextBox 3"/>
+          <p:cNvSpPr txBox="1"/>
+          <p:nvPr/>
+        </p:nvSpPr>
+        <p:spPr>
+          <a:xfrm>
+            <a:off x="914400" y="1645920"/>
+            <a:ext cx="10515600" cy="548640"/>
+          </a:xfrm>
+          <a:prstGeom prst="rect">
+            <a:avLst/>
+          </a:prstGeom>
+          <a:noFill/>
+        </p:spPr>
+        <p:txBody>
+          <a:bodyPr wrap="square" lIns="45720" rIns="45720" tIns="27432" bIns="27432">
+            <a:spAutoFit/>
+          </a:bodyPr>
+          <a:lstStyle/>
+          <a:p>
+            <a:pPr algn="l"/>
+            <a:r>
+              <a:rPr sz="1800" b="0" i="0">
+                <a:solidFill>
+                  <a:srgbClr val="CADCFC"/>
+                </a:solidFill>
+                <a:latin typeface="Calibri"/>
+              </a:rPr>
+              <a:t>Three DSP-anchored hyperparameters define the design</a:t>
+            </a:r>
+          </a:p>
+        </p:txBody>
+      </p:sp>
+      <p:sp>
+        <p:nvSpPr>
+          <p:cNvPr id="5" name="Rounded Rectangle 4"/>
           <p:cNvSpPr/>
           <p:nvPr/>
         </p:nvSpPr>
         <p:spPr>
           <a:xfrm>
-            <a:off x="0" y="0"/>
-            <a:ext cx="365760" cy="6858000"/>
-          </a:xfrm>
-          <a:prstGeom prst="rect">
+            <a:off x="914400" y="2834640"/>
+            <a:ext cx="10332720" cy="822960"/>
+          </a:xfrm>
+          <a:prstGeom prst="roundRect">
             <a:avLst/>
           </a:prstGeom>
           <a:solidFill>
-            <a:srgbClr val="F5A623"/>
+            <a:srgbClr val="065A82"/>
           </a:solidFill>
           <a:ln>
             <a:noFill/>
@@ -10279,14 +9833,14 @@
       </p:sp>
       <p:sp>
         <p:nvSpPr>
-          <p:cNvPr id="4" name="TextBox 3"/>
+          <p:cNvPr id="6" name="TextBox 5"/>
           <p:cNvSpPr txBox="1"/>
           <p:nvPr/>
         </p:nvSpPr>
         <p:spPr>
           <a:xfrm>
-            <a:off x="914400" y="731520"/>
-            <a:ext cx="10515600" cy="914400"/>
+            <a:off x="1188720" y="3017520"/>
+            <a:ext cx="3200400" cy="457200"/>
           </a:xfrm>
           <a:prstGeom prst="rect">
             <a:avLst/>
@@ -10301,27 +9855,27 @@
           <a:p>
             <a:pPr algn="l"/>
             <a:r>
-              <a:rPr sz="3800" b="1" i="0">
-                <a:solidFill>
-                  <a:srgbClr val="F2F4F8"/>
-                </a:solidFill>
-                <a:latin typeface="Calibri"/>
-              </a:rPr>
-              <a:t>Key Takeaway</a:t>
-            </a:r>
-          </a:p>
-        </p:txBody>
-      </p:sp>
-      <p:sp>
-        <p:nvSpPr>
-          <p:cNvPr id="5" name="TextBox 4"/>
+              <a:rPr sz="2000" b="1" i="0">
+                <a:solidFill>
+                  <a:srgbClr val="F5A623"/>
+                </a:solidFill>
+                <a:latin typeface="Calibri"/>
+              </a:rPr>
+              <a:t>n_heads</a:t>
+            </a:r>
+          </a:p>
+        </p:txBody>
+      </p:sp>
+      <p:sp>
+        <p:nvSpPr>
+          <p:cNvPr id="7" name="TextBox 6"/>
           <p:cNvSpPr txBox="1"/>
           <p:nvPr/>
         </p:nvSpPr>
         <p:spPr>
           <a:xfrm>
-            <a:off x="914400" y="1645920"/>
-            <a:ext cx="10515600" cy="548640"/>
+            <a:off x="4572000" y="3017520"/>
+            <a:ext cx="6400800" cy="457200"/>
           </a:xfrm>
           <a:prstGeom prst="rect">
             <a:avLst/>
@@ -10336,26 +9890,26 @@
           <a:p>
             <a:pPr algn="l"/>
             <a:r>
-              <a:rPr sz="1800" b="0" i="0">
-                <a:solidFill>
-                  <a:srgbClr val="CADCFC"/>
-                </a:solidFill>
-                <a:latin typeface="Calibri"/>
-              </a:rPr>
-              <a:t>Three DSP-anchored hyperparameters define the design</a:t>
-            </a:r>
-          </a:p>
-        </p:txBody>
-      </p:sp>
-      <p:sp>
-        <p:nvSpPr>
-          <p:cNvPr id="6" name="Rounded Rectangle 5"/>
+              <a:rPr sz="2000" b="0" i="0">
+                <a:solidFill>
+                  <a:srgbClr val="F2F4F8"/>
+                </a:solidFill>
+                <a:latin typeface="Calibri"/>
+              </a:rPr>
+              <a:t>≈  effective AR order</a:t>
+            </a:r>
+          </a:p>
+        </p:txBody>
+      </p:sp>
+      <p:sp>
+        <p:nvSpPr>
+          <p:cNvPr id="8" name="Rounded Rectangle 7"/>
           <p:cNvSpPr/>
           <p:nvPr/>
         </p:nvSpPr>
         <p:spPr>
           <a:xfrm>
-            <a:off x="914400" y="2834640"/>
+            <a:off x="914400" y="3794760"/>
             <a:ext cx="10332720" cy="822960"/>
           </a:xfrm>
           <a:prstGeom prst="roundRect">
@@ -10392,13 +9946,13 @@
       </p:sp>
       <p:sp>
         <p:nvSpPr>
-          <p:cNvPr id="7" name="TextBox 6"/>
+          <p:cNvPr id="9" name="TextBox 8"/>
           <p:cNvSpPr txBox="1"/>
           <p:nvPr/>
         </p:nvSpPr>
         <p:spPr>
           <a:xfrm>
-            <a:off x="1188720" y="3017520"/>
+            <a:off x="1188720" y="3977640"/>
             <a:ext cx="3200400" cy="457200"/>
           </a:xfrm>
           <a:prstGeom prst="rect">
@@ -10420,20 +9974,20 @@
                 </a:solidFill>
                 <a:latin typeface="Calibri"/>
               </a:rPr>
-              <a:t>n_heads</a:t>
-            </a:r>
-          </a:p>
-        </p:txBody>
-      </p:sp>
-      <p:sp>
-        <p:nvSpPr>
-          <p:cNvPr id="8" name="TextBox 7"/>
+              <a:t>context_length</a:t>
+            </a:r>
+          </a:p>
+        </p:txBody>
+      </p:sp>
+      <p:sp>
+        <p:nvSpPr>
+          <p:cNvPr id="10" name="TextBox 9"/>
           <p:cNvSpPr txBox="1"/>
           <p:nvPr/>
         </p:nvSpPr>
         <p:spPr>
           <a:xfrm>
-            <a:off x="4572000" y="3017520"/>
+            <a:off x="4572000" y="3977640"/>
             <a:ext cx="6400800" cy="457200"/>
           </a:xfrm>
           <a:prstGeom prst="rect">
@@ -10455,20 +10009,20 @@
                 </a:solidFill>
                 <a:latin typeface="Calibri"/>
               </a:rPr>
-              <a:t>≈  effective AR order</a:t>
-            </a:r>
-          </a:p>
-        </p:txBody>
-      </p:sp>
-      <p:sp>
-        <p:nvSpPr>
-          <p:cNvPr id="9" name="Rounded Rectangle 8"/>
+              <a:t>≈  N_FFT  ≈  fs / f_min</a:t>
+            </a:r>
+          </a:p>
+        </p:txBody>
+      </p:sp>
+      <p:sp>
+        <p:nvSpPr>
+          <p:cNvPr id="11" name="Rounded Rectangle 10"/>
           <p:cNvSpPr/>
           <p:nvPr/>
         </p:nvSpPr>
         <p:spPr>
           <a:xfrm>
-            <a:off x="914400" y="3794760"/>
+            <a:off x="914400" y="4754880"/>
             <a:ext cx="10332720" cy="822960"/>
           </a:xfrm>
           <a:prstGeom prst="roundRect">
@@ -10505,13 +10059,13 @@
       </p:sp>
       <p:sp>
         <p:nvSpPr>
-          <p:cNvPr id="10" name="TextBox 9"/>
+          <p:cNvPr id="12" name="TextBox 11"/>
           <p:cNvSpPr txBox="1"/>
           <p:nvPr/>
         </p:nvSpPr>
         <p:spPr>
           <a:xfrm>
-            <a:off x="1188720" y="3977640"/>
+            <a:off x="1188720" y="4937760"/>
             <a:ext cx="3200400" cy="457200"/>
           </a:xfrm>
           <a:prstGeom prst="rect">
@@ -10533,20 +10087,20 @@
                 </a:solidFill>
                 <a:latin typeface="Calibri"/>
               </a:rPr>
-              <a:t>context_length</a:t>
-            </a:r>
-          </a:p>
-        </p:txBody>
-      </p:sp>
-      <p:sp>
-        <p:nvSpPr>
-          <p:cNvPr id="11" name="TextBox 10"/>
+              <a:t>head_dim</a:t>
+            </a:r>
+          </a:p>
+        </p:txBody>
+      </p:sp>
+      <p:sp>
+        <p:nvSpPr>
+          <p:cNvPr id="13" name="TextBox 12"/>
           <p:cNvSpPr txBox="1"/>
           <p:nvPr/>
         </p:nvSpPr>
         <p:spPr>
           <a:xfrm>
-            <a:off x="4572000" y="3977640"/>
+            <a:off x="4572000" y="4937760"/>
             <a:ext cx="6400800" cy="457200"/>
           </a:xfrm>
           <a:prstGeom prst="rect">
@@ -10568,85 +10122,7 @@
                 </a:solidFill>
                 <a:latin typeface="Calibri"/>
               </a:rPr>
-              <a:t>≈  N_FFT  ≈  fs / f_min</a:t>
-            </a:r>
-          </a:p>
-        </p:txBody>
-      </p:sp>
-      <p:sp>
-        <p:nvSpPr>
-          <p:cNvPr id="12" name="Rounded Rectangle 11"/>
-          <p:cNvSpPr/>
-          <p:nvPr/>
-        </p:nvSpPr>
-        <p:spPr>
-          <a:xfrm>
-            <a:off x="914400" y="4754880"/>
-            <a:ext cx="10332720" cy="822960"/>
-          </a:xfrm>
-          <a:prstGeom prst="roundRect">
-            <a:avLst/>
-          </a:prstGeom>
-          <a:solidFill>
-            <a:srgbClr val="065A82"/>
-          </a:solidFill>
-          <a:ln>
-            <a:noFill/>
-          </a:ln>
-        </p:spPr>
-        <p:style>
-          <a:lnRef idx="1">
-            <a:schemeClr val="accent1"/>
-          </a:lnRef>
-          <a:fillRef idx="3">
-            <a:schemeClr val="accent1"/>
-          </a:fillRef>
-          <a:effectRef idx="2">
-            <a:schemeClr val="accent1"/>
-          </a:effectRef>
-          <a:fontRef idx="minor">
-            <a:schemeClr val="lt1"/>
-          </a:fontRef>
-        </p:style>
-        <p:txBody>
-          <a:bodyPr rtlCol="0" anchor="ctr"/>
-          <a:lstStyle/>
-          <a:p>
-            <a:pPr algn="ctr"/>
-          </a:p>
-        </p:txBody>
-      </p:sp>
-      <p:sp>
-        <p:nvSpPr>
-          <p:cNvPr id="13" name="TextBox 12"/>
-          <p:cNvSpPr txBox="1"/>
-          <p:nvPr/>
-        </p:nvSpPr>
-        <p:spPr>
-          <a:xfrm>
-            <a:off x="1188720" y="4937760"/>
-            <a:ext cx="3200400" cy="457200"/>
-          </a:xfrm>
-          <a:prstGeom prst="rect">
-            <a:avLst/>
-          </a:prstGeom>
-          <a:noFill/>
-        </p:spPr>
-        <p:txBody>
-          <a:bodyPr wrap="square" lIns="45720" rIns="45720" tIns="27432" bIns="27432">
-            <a:spAutoFit/>
-          </a:bodyPr>
-          <a:lstStyle/>
-          <a:p>
-            <a:pPr algn="l"/>
-            <a:r>
-              <a:rPr sz="2000" b="1" i="0">
-                <a:solidFill>
-                  <a:srgbClr val="F5A623"/>
-                </a:solidFill>
-                <a:latin typeface="Calibri"/>
-              </a:rPr>
-              <a:t>head_dim</a:t>
+              <a:t>≈  2 · log₂(context_length)</a:t>
             </a:r>
           </a:p>
         </p:txBody>
@@ -10654,41 +10130,6 @@
       <p:sp>
         <p:nvSpPr>
           <p:cNvPr id="14" name="TextBox 13"/>
-          <p:cNvSpPr txBox="1"/>
-          <p:nvPr/>
-        </p:nvSpPr>
-        <p:spPr>
-          <a:xfrm>
-            <a:off x="4572000" y="4937760"/>
-            <a:ext cx="6400800" cy="457200"/>
-          </a:xfrm>
-          <a:prstGeom prst="rect">
-            <a:avLst/>
-          </a:prstGeom>
-          <a:noFill/>
-        </p:spPr>
-        <p:txBody>
-          <a:bodyPr wrap="square" lIns="45720" rIns="45720" tIns="27432" bIns="27432">
-            <a:spAutoFit/>
-          </a:bodyPr>
-          <a:lstStyle/>
-          <a:p>
-            <a:pPr algn="l"/>
-            <a:r>
-              <a:rPr sz="2000" b="0" i="0">
-                <a:solidFill>
-                  <a:srgbClr val="F2F4F8"/>
-                </a:solidFill>
-                <a:latin typeface="Calibri"/>
-              </a:rPr>
-              <a:t>≈  2 · log₂(context_length)</a:t>
-            </a:r>
-          </a:p>
-        </p:txBody>
-      </p:sp>
-      <p:sp>
-        <p:nvSpPr>
-          <p:cNvPr id="15" name="TextBox 14"/>
           <p:cNvSpPr txBox="1"/>
           <p:nvPr/>
         </p:nvSpPr>
@@ -10855,20 +10296,20 @@
       </p:sp>
       <p:sp>
         <p:nvSpPr>
-          <p:cNvPr id="5" name="Rectangle 4"/>
+          <p:cNvPr id="5" name="Rounded Rectangle 4"/>
           <p:cNvSpPr/>
           <p:nvPr/>
         </p:nvSpPr>
         <p:spPr>
           <a:xfrm>
-            <a:off x="548640" y="1508760"/>
-            <a:ext cx="109728" cy="548640"/>
-          </a:xfrm>
-          <a:prstGeom prst="rect">
+            <a:off x="1371600" y="2103120"/>
+            <a:ext cx="9418320" cy="1463040"/>
+          </a:xfrm>
+          <a:prstGeom prst="roundRect">
             <a:avLst/>
           </a:prstGeom>
           <a:solidFill>
-            <a:srgbClr val="F5A623"/>
+            <a:srgbClr val="065A82"/>
           </a:solidFill>
           <a:ln>
             <a:noFill/>
@@ -10898,50 +10339,7 @@
       </p:sp>
       <p:sp>
         <p:nvSpPr>
-          <p:cNvPr id="6" name="Rounded Rectangle 5"/>
-          <p:cNvSpPr/>
-          <p:nvPr/>
-        </p:nvSpPr>
-        <p:spPr>
-          <a:xfrm>
-            <a:off x="1371600" y="2103120"/>
-            <a:ext cx="9418320" cy="1463040"/>
-          </a:xfrm>
-          <a:prstGeom prst="roundRect">
-            <a:avLst/>
-          </a:prstGeom>
-          <a:solidFill>
-            <a:srgbClr val="065A82"/>
-          </a:solidFill>
-          <a:ln>
-            <a:noFill/>
-          </a:ln>
-        </p:spPr>
-        <p:style>
-          <a:lnRef idx="1">
-            <a:schemeClr val="accent1"/>
-          </a:lnRef>
-          <a:fillRef idx="3">
-            <a:schemeClr val="accent1"/>
-          </a:fillRef>
-          <a:effectRef idx="2">
-            <a:schemeClr val="accent1"/>
-          </a:effectRef>
-          <a:fontRef idx="minor">
-            <a:schemeClr val="lt1"/>
-          </a:fontRef>
-        </p:style>
-        <p:txBody>
-          <a:bodyPr rtlCol="0" anchor="ctr"/>
-          <a:lstStyle/>
-          <a:p>
-            <a:pPr algn="ctr"/>
-          </a:p>
-        </p:txBody>
-      </p:sp>
-      <p:sp>
-        <p:nvSpPr>
-          <p:cNvPr id="7" name="TextBox 6"/>
+          <p:cNvPr id="6" name="TextBox 5"/>
           <p:cNvSpPr txBox="1"/>
           <p:nvPr/>
         </p:nvSpPr>
@@ -10976,7 +10374,7 @@
       </p:sp>
       <p:sp>
         <p:nvSpPr>
-          <p:cNvPr id="8" name="TextBox 7"/>
+          <p:cNvPr id="7" name="TextBox 6"/>
           <p:cNvSpPr txBox="1"/>
           <p:nvPr/>
         </p:nvSpPr>
@@ -11011,7 +10409,7 @@
       </p:sp>
       <p:sp>
         <p:nvSpPr>
-          <p:cNvPr id="9" name="TextBox 8"/>
+          <p:cNvPr id="8" name="TextBox 7"/>
           <p:cNvSpPr txBox="1"/>
           <p:nvPr/>
         </p:nvSpPr>
@@ -11212,52 +10610,9 @@
           </a:p>
         </p:txBody>
       </p:sp>
-      <p:sp>
-        <p:nvSpPr>
-          <p:cNvPr id="5" name="Rectangle 4"/>
-          <p:cNvSpPr/>
-          <p:nvPr/>
-        </p:nvSpPr>
-        <p:spPr>
-          <a:xfrm>
-            <a:off x="548640" y="1508760"/>
-            <a:ext cx="109728" cy="548640"/>
-          </a:xfrm>
-          <a:prstGeom prst="rect">
-            <a:avLst/>
-          </a:prstGeom>
-          <a:solidFill>
-            <a:srgbClr val="F5A623"/>
-          </a:solidFill>
-          <a:ln>
-            <a:noFill/>
-          </a:ln>
-        </p:spPr>
-        <p:style>
-          <a:lnRef idx="1">
-            <a:schemeClr val="accent1"/>
-          </a:lnRef>
-          <a:fillRef idx="3">
-            <a:schemeClr val="accent1"/>
-          </a:fillRef>
-          <a:effectRef idx="2">
-            <a:schemeClr val="accent1"/>
-          </a:effectRef>
-          <a:fontRef idx="minor">
-            <a:schemeClr val="lt1"/>
-          </a:fontRef>
-        </p:style>
-        <p:txBody>
-          <a:bodyPr rtlCol="0" anchor="ctr"/>
-          <a:lstStyle/>
-          <a:p>
-            <a:pPr algn="ctr"/>
-          </a:p>
-        </p:txBody>
-      </p:sp>
       <p:graphicFrame>
         <p:nvGraphicFramePr>
-          <p:cNvPr id="6" name="Table 5"/>
+          <p:cNvPr id="5" name="Table 4"/>
           <p:cNvGraphicFramePr>
             <a:graphicFrameLocks noGrp="1"/>
           </p:cNvGraphicFramePr>
@@ -11828,7 +11183,7 @@
       </p:graphicFrame>
       <p:sp>
         <p:nvSpPr>
-          <p:cNvPr id="7" name="TextBox 6"/>
+          <p:cNvPr id="6" name="TextBox 5"/>
           <p:cNvSpPr txBox="1"/>
           <p:nvPr/>
         </p:nvSpPr>
@@ -11995,20 +11350,20 @@
       </p:sp>
       <p:sp>
         <p:nvSpPr>
-          <p:cNvPr id="5" name="Rectangle 4"/>
+          <p:cNvPr id="5" name="Rounded Rectangle 4"/>
           <p:cNvSpPr/>
           <p:nvPr/>
         </p:nvSpPr>
         <p:spPr>
           <a:xfrm>
-            <a:off x="548640" y="1508760"/>
-            <a:ext cx="109728" cy="548640"/>
-          </a:xfrm>
-          <a:prstGeom prst="rect">
+            <a:off x="411480" y="2286000"/>
+            <a:ext cx="1508760" cy="1188720"/>
+          </a:xfrm>
+          <a:prstGeom prst="roundRect">
             <a:avLst/>
           </a:prstGeom>
           <a:solidFill>
-            <a:srgbClr val="F5A623"/>
+            <a:srgbClr val="B8C7D8"/>
           </a:solidFill>
           <a:ln>
             <a:noFill/>
@@ -12029,29 +11384,50 @@
           </a:fontRef>
         </p:style>
         <p:txBody>
-          <a:bodyPr rtlCol="0" anchor="ctr"/>
+          <a:bodyPr rtlCol="0" anchor="ctr" lIns="45720" rIns="45720" wrap="square"/>
           <a:lstStyle/>
           <a:p>
             <a:pPr algn="ctr"/>
-          </a:p>
-        </p:txBody>
-      </p:sp>
-      <p:sp>
-        <p:nvSpPr>
-          <p:cNvPr id="6" name="Rounded Rectangle 5"/>
+            <a:r>
+              <a:rPr sz="1200" b="1">
+                <a:solidFill>
+                  <a:srgbClr val="1A1A1A"/>
+                </a:solidFill>
+                <a:latin typeface="Calibri"/>
+              </a:rPr>
+              <a:t>Scalar</a:t>
+            </a:r>
+          </a:p>
+          <a:p>
+            <a:pPr algn="ctr"/>
+            <a:r>
+              <a:rPr sz="1200" b="1">
+                <a:solidFill>
+                  <a:srgbClr val="1A1A1A"/>
+                </a:solidFill>
+                <a:latin typeface="Calibri"/>
+              </a:rPr>
+              <a:t>sample</a:t>
+            </a:r>
+          </a:p>
+        </p:txBody>
+      </p:sp>
+      <p:sp>
+        <p:nvSpPr>
+          <p:cNvPr id="6" name="Right Arrow 5"/>
           <p:cNvSpPr/>
           <p:nvPr/>
         </p:nvSpPr>
         <p:spPr>
           <a:xfrm>
-            <a:off x="411480" y="2286000"/>
-            <a:ext cx="1508760" cy="1188720"/>
-          </a:xfrm>
-          <a:prstGeom prst="roundRect">
+            <a:off x="1920240" y="2743200"/>
+            <a:ext cx="164592" cy="274320"/>
+          </a:xfrm>
+          <a:prstGeom prst="rightArrow">
             <a:avLst/>
           </a:prstGeom>
           <a:solidFill>
-            <a:srgbClr val="B8C7D8"/>
+            <a:srgbClr val="555F6D"/>
           </a:solidFill>
           <a:ln>
             <a:noFill/>
@@ -12072,50 +11448,29 @@
           </a:fontRef>
         </p:style>
         <p:txBody>
-          <a:bodyPr rtlCol="0" anchor="ctr" lIns="45720" rIns="45720" wrap="square"/>
+          <a:bodyPr rtlCol="0" anchor="ctr"/>
           <a:lstStyle/>
           <a:p>
             <a:pPr algn="ctr"/>
-            <a:r>
-              <a:rPr sz="1200" b="1">
-                <a:solidFill>
-                  <a:srgbClr val="1A1A1A"/>
-                </a:solidFill>
-                <a:latin typeface="Calibri"/>
-              </a:rPr>
-              <a:t>Scalar</a:t>
-            </a:r>
-          </a:p>
-          <a:p>
-            <a:pPr algn="ctr"/>
-            <a:r>
-              <a:rPr sz="1200" b="1">
-                <a:solidFill>
-                  <a:srgbClr val="1A1A1A"/>
-                </a:solidFill>
-                <a:latin typeface="Calibri"/>
-              </a:rPr>
-              <a:t>sample</a:t>
-            </a:r>
-          </a:p>
-        </p:txBody>
-      </p:sp>
-      <p:sp>
-        <p:nvSpPr>
-          <p:cNvPr id="7" name="Right Arrow 6"/>
+          </a:p>
+        </p:txBody>
+      </p:sp>
+      <p:sp>
+        <p:nvSpPr>
+          <p:cNvPr id="7" name="Rounded Rectangle 6"/>
           <p:cNvSpPr/>
           <p:nvPr/>
         </p:nvSpPr>
         <p:spPr>
           <a:xfrm>
-            <a:off x="1920240" y="2743200"/>
-            <a:ext cx="164592" cy="274320"/>
-          </a:xfrm>
-          <a:prstGeom prst="rightArrow">
+            <a:off x="2084832" y="2286000"/>
+            <a:ext cx="1508760" cy="1188720"/>
+          </a:xfrm>
+          <a:prstGeom prst="roundRect">
             <a:avLst/>
           </a:prstGeom>
           <a:solidFill>
-            <a:srgbClr val="555F6D"/>
+            <a:srgbClr val="1C7293"/>
           </a:solidFill>
           <a:ln>
             <a:noFill/>
@@ -12136,29 +11491,50 @@
           </a:fontRef>
         </p:style>
         <p:txBody>
-          <a:bodyPr rtlCol="0" anchor="ctr"/>
+          <a:bodyPr rtlCol="0" anchor="ctr" lIns="45720" rIns="45720" wrap="square"/>
           <a:lstStyle/>
           <a:p>
             <a:pPr algn="ctr"/>
-          </a:p>
-        </p:txBody>
-      </p:sp>
-      <p:sp>
-        <p:nvSpPr>
-          <p:cNvPr id="8" name="Rounded Rectangle 7"/>
+            <a:r>
+              <a:rPr sz="1200" b="1">
+                <a:solidFill>
+                  <a:srgbClr val="F2F4F8"/>
+                </a:solidFill>
+                <a:latin typeface="Calibri"/>
+              </a:rPr>
+              <a:t>Linear(1,32)</a:t>
+            </a:r>
+          </a:p>
+          <a:p>
+            <a:pPr algn="ctr"/>
+            <a:r>
+              <a:rPr sz="1200" b="1">
+                <a:solidFill>
+                  <a:srgbClr val="F2F4F8"/>
+                </a:solidFill>
+                <a:latin typeface="Calibri"/>
+              </a:rPr>
+              <a:t>input proj</a:t>
+            </a:r>
+          </a:p>
+        </p:txBody>
+      </p:sp>
+      <p:sp>
+        <p:nvSpPr>
+          <p:cNvPr id="8" name="Right Arrow 7"/>
           <p:cNvSpPr/>
           <p:nvPr/>
         </p:nvSpPr>
         <p:spPr>
           <a:xfrm>
-            <a:off x="2084832" y="2286000"/>
-            <a:ext cx="1508760" cy="1188720"/>
-          </a:xfrm>
-          <a:prstGeom prst="roundRect">
+            <a:off x="3593592" y="2743200"/>
+            <a:ext cx="164592" cy="274320"/>
+          </a:xfrm>
+          <a:prstGeom prst="rightArrow">
             <a:avLst/>
           </a:prstGeom>
           <a:solidFill>
-            <a:srgbClr val="1C7293"/>
+            <a:srgbClr val="555F6D"/>
           </a:solidFill>
           <a:ln>
             <a:noFill/>
@@ -12179,50 +11555,29 @@
           </a:fontRef>
         </p:style>
         <p:txBody>
-          <a:bodyPr rtlCol="0" anchor="ctr" lIns="45720" rIns="45720" wrap="square"/>
+          <a:bodyPr rtlCol="0" anchor="ctr"/>
           <a:lstStyle/>
           <a:p>
             <a:pPr algn="ctr"/>
-            <a:r>
-              <a:rPr sz="1200" b="1">
-                <a:solidFill>
-                  <a:srgbClr val="F2F4F8"/>
-                </a:solidFill>
-                <a:latin typeface="Calibri"/>
-              </a:rPr>
-              <a:t>Linear(1,32)</a:t>
-            </a:r>
-          </a:p>
-          <a:p>
-            <a:pPr algn="ctr"/>
-            <a:r>
-              <a:rPr sz="1200" b="1">
-                <a:solidFill>
-                  <a:srgbClr val="F2F4F8"/>
-                </a:solidFill>
-                <a:latin typeface="Calibri"/>
-              </a:rPr>
-              <a:t>input proj</a:t>
-            </a:r>
-          </a:p>
-        </p:txBody>
-      </p:sp>
-      <p:sp>
-        <p:nvSpPr>
-          <p:cNvPr id="9" name="Right Arrow 8"/>
+          </a:p>
+        </p:txBody>
+      </p:sp>
+      <p:sp>
+        <p:nvSpPr>
+          <p:cNvPr id="9" name="Rounded Rectangle 8"/>
           <p:cNvSpPr/>
           <p:nvPr/>
         </p:nvSpPr>
         <p:spPr>
           <a:xfrm>
-            <a:off x="3593592" y="2743200"/>
-            <a:ext cx="164592" cy="274320"/>
-          </a:xfrm>
-          <a:prstGeom prst="rightArrow">
+            <a:off x="3758184" y="2286000"/>
+            <a:ext cx="1508760" cy="1188720"/>
+          </a:xfrm>
+          <a:prstGeom prst="roundRect">
             <a:avLst/>
           </a:prstGeom>
           <a:solidFill>
-            <a:srgbClr val="555F6D"/>
+            <a:srgbClr val="1C7293"/>
           </a:solidFill>
           <a:ln>
             <a:noFill/>
@@ -12243,29 +11598,50 @@
           </a:fontRef>
         </p:style>
         <p:txBody>
-          <a:bodyPr rtlCol="0" anchor="ctr"/>
+          <a:bodyPr rtlCol="0" anchor="ctr" lIns="45720" rIns="45720" wrap="square"/>
           <a:lstStyle/>
           <a:p>
             <a:pPr algn="ctr"/>
-          </a:p>
-        </p:txBody>
-      </p:sp>
-      <p:sp>
-        <p:nvSpPr>
-          <p:cNvPr id="10" name="Rounded Rectangle 9"/>
+            <a:r>
+              <a:rPr sz="1200" b="1">
+                <a:solidFill>
+                  <a:srgbClr val="F2F4F8"/>
+                </a:solidFill>
+                <a:latin typeface="Calibri"/>
+              </a:rPr>
+              <a:t>+ pos emb</a:t>
+            </a:r>
+          </a:p>
+          <a:p>
+            <a:pPr algn="ctr"/>
+            <a:r>
+              <a:rPr sz="1200" b="1">
+                <a:solidFill>
+                  <a:srgbClr val="F2F4F8"/>
+                </a:solidFill>
+                <a:latin typeface="Calibri"/>
+              </a:rPr>
+              <a:t>(128×32)</a:t>
+            </a:r>
+          </a:p>
+        </p:txBody>
+      </p:sp>
+      <p:sp>
+        <p:nvSpPr>
+          <p:cNvPr id="10" name="Right Arrow 9"/>
           <p:cNvSpPr/>
           <p:nvPr/>
         </p:nvSpPr>
         <p:spPr>
           <a:xfrm>
-            <a:off x="3758184" y="2286000"/>
-            <a:ext cx="1508760" cy="1188720"/>
-          </a:xfrm>
-          <a:prstGeom prst="roundRect">
+            <a:off x="5266944" y="2743200"/>
+            <a:ext cx="164592" cy="274320"/>
+          </a:xfrm>
+          <a:prstGeom prst="rightArrow">
             <a:avLst/>
           </a:prstGeom>
           <a:solidFill>
-            <a:srgbClr val="1C7293"/>
+            <a:srgbClr val="555F6D"/>
           </a:solidFill>
           <a:ln>
             <a:noFill/>
@@ -12286,50 +11662,29 @@
           </a:fontRef>
         </p:style>
         <p:txBody>
-          <a:bodyPr rtlCol="0" anchor="ctr" lIns="45720" rIns="45720" wrap="square"/>
+          <a:bodyPr rtlCol="0" anchor="ctr"/>
           <a:lstStyle/>
           <a:p>
             <a:pPr algn="ctr"/>
-            <a:r>
-              <a:rPr sz="1200" b="1">
-                <a:solidFill>
-                  <a:srgbClr val="F2F4F8"/>
-                </a:solidFill>
-                <a:latin typeface="Calibri"/>
-              </a:rPr>
-              <a:t>+ pos emb</a:t>
-            </a:r>
-          </a:p>
-          <a:p>
-            <a:pPr algn="ctr"/>
-            <a:r>
-              <a:rPr sz="1200" b="1">
-                <a:solidFill>
-                  <a:srgbClr val="F2F4F8"/>
-                </a:solidFill>
-                <a:latin typeface="Calibri"/>
-              </a:rPr>
-              <a:t>(128×32)</a:t>
-            </a:r>
-          </a:p>
-        </p:txBody>
-      </p:sp>
-      <p:sp>
-        <p:nvSpPr>
-          <p:cNvPr id="11" name="Right Arrow 10"/>
+          </a:p>
+        </p:txBody>
+      </p:sp>
+      <p:sp>
+        <p:nvSpPr>
+          <p:cNvPr id="11" name="Rounded Rectangle 10"/>
           <p:cNvSpPr/>
           <p:nvPr/>
         </p:nvSpPr>
         <p:spPr>
           <a:xfrm>
-            <a:off x="5266944" y="2743200"/>
-            <a:ext cx="164592" cy="274320"/>
-          </a:xfrm>
-          <a:prstGeom prst="rightArrow">
+            <a:off x="5431536" y="2286000"/>
+            <a:ext cx="1508760" cy="1188720"/>
+          </a:xfrm>
+          <a:prstGeom prst="roundRect">
             <a:avLst/>
           </a:prstGeom>
           <a:solidFill>
-            <a:srgbClr val="555F6D"/>
+            <a:srgbClr val="065A82"/>
           </a:solidFill>
           <a:ln>
             <a:noFill/>
@@ -12350,29 +11705,50 @@
           </a:fontRef>
         </p:style>
         <p:txBody>
-          <a:bodyPr rtlCol="0" anchor="ctr"/>
+          <a:bodyPr rtlCol="0" anchor="ctr" lIns="45720" rIns="45720" wrap="square"/>
           <a:lstStyle/>
           <a:p>
             <a:pPr algn="ctr"/>
-          </a:p>
-        </p:txBody>
-      </p:sp>
-      <p:sp>
-        <p:nvSpPr>
-          <p:cNvPr id="12" name="Rounded Rectangle 11"/>
+            <a:r>
+              <a:rPr sz="1200" b="1">
+                <a:solidFill>
+                  <a:srgbClr val="F2F4F8"/>
+                </a:solidFill>
+                <a:latin typeface="Calibri"/>
+              </a:rPr>
+              <a:t>Trf block ×2</a:t>
+            </a:r>
+          </a:p>
+          <a:p>
+            <a:pPr algn="ctr"/>
+            <a:r>
+              <a:rPr sz="1200" b="1">
+                <a:solidFill>
+                  <a:srgbClr val="F2F4F8"/>
+                </a:solidFill>
+                <a:latin typeface="Calibri"/>
+              </a:rPr>
+              <a:t>2 heads, 32 dim</a:t>
+            </a:r>
+          </a:p>
+        </p:txBody>
+      </p:sp>
+      <p:sp>
+        <p:nvSpPr>
+          <p:cNvPr id="12" name="Right Arrow 11"/>
           <p:cNvSpPr/>
           <p:nvPr/>
         </p:nvSpPr>
         <p:spPr>
           <a:xfrm>
-            <a:off x="5431536" y="2286000"/>
-            <a:ext cx="1508760" cy="1188720"/>
-          </a:xfrm>
-          <a:prstGeom prst="roundRect">
+            <a:off x="6940296" y="2743200"/>
+            <a:ext cx="164592" cy="274320"/>
+          </a:xfrm>
+          <a:prstGeom prst="rightArrow">
             <a:avLst/>
           </a:prstGeom>
           <a:solidFill>
-            <a:srgbClr val="065A82"/>
+            <a:srgbClr val="555F6D"/>
           </a:solidFill>
           <a:ln>
             <a:noFill/>
@@ -12393,50 +11769,29 @@
           </a:fontRef>
         </p:style>
         <p:txBody>
-          <a:bodyPr rtlCol="0" anchor="ctr" lIns="45720" rIns="45720" wrap="square"/>
+          <a:bodyPr rtlCol="0" anchor="ctr"/>
           <a:lstStyle/>
           <a:p>
             <a:pPr algn="ctr"/>
-            <a:r>
-              <a:rPr sz="1200" b="1">
-                <a:solidFill>
-                  <a:srgbClr val="F2F4F8"/>
-                </a:solidFill>
-                <a:latin typeface="Calibri"/>
-              </a:rPr>
-              <a:t>Trf block ×2</a:t>
-            </a:r>
-          </a:p>
-          <a:p>
-            <a:pPr algn="ctr"/>
-            <a:r>
-              <a:rPr sz="1200" b="1">
-                <a:solidFill>
-                  <a:srgbClr val="F2F4F8"/>
-                </a:solidFill>
-                <a:latin typeface="Calibri"/>
-              </a:rPr>
-              <a:t>2 heads, 32 dim</a:t>
-            </a:r>
-          </a:p>
-        </p:txBody>
-      </p:sp>
-      <p:sp>
-        <p:nvSpPr>
-          <p:cNvPr id="13" name="Right Arrow 12"/>
+          </a:p>
+        </p:txBody>
+      </p:sp>
+      <p:sp>
+        <p:nvSpPr>
+          <p:cNvPr id="13" name="Rounded Rectangle 12"/>
           <p:cNvSpPr/>
           <p:nvPr/>
         </p:nvSpPr>
         <p:spPr>
           <a:xfrm>
-            <a:off x="6940296" y="2743200"/>
-            <a:ext cx="164592" cy="274320"/>
-          </a:xfrm>
-          <a:prstGeom prst="rightArrow">
+            <a:off x="7104888" y="2286000"/>
+            <a:ext cx="1508760" cy="1188720"/>
+          </a:xfrm>
+          <a:prstGeom prst="roundRect">
             <a:avLst/>
           </a:prstGeom>
           <a:solidFill>
-            <a:srgbClr val="555F6D"/>
+            <a:srgbClr val="1C7293"/>
           </a:solidFill>
           <a:ln>
             <a:noFill/>
@@ -12457,29 +11812,38 @@
           </a:fontRef>
         </p:style>
         <p:txBody>
-          <a:bodyPr rtlCol="0" anchor="ctr"/>
+          <a:bodyPr rtlCol="0" anchor="ctr" lIns="45720" rIns="45720" wrap="square"/>
           <a:lstStyle/>
           <a:p>
             <a:pPr algn="ctr"/>
-          </a:p>
-        </p:txBody>
-      </p:sp>
-      <p:sp>
-        <p:nvSpPr>
-          <p:cNvPr id="14" name="Rounded Rectangle 13"/>
+            <a:r>
+              <a:rPr sz="1200" b="1">
+                <a:solidFill>
+                  <a:srgbClr val="F2F4F8"/>
+                </a:solidFill>
+                <a:latin typeface="Calibri"/>
+              </a:rPr>
+              <a:t>LayerNorm</a:t>
+            </a:r>
+          </a:p>
+        </p:txBody>
+      </p:sp>
+      <p:sp>
+        <p:nvSpPr>
+          <p:cNvPr id="14" name="Right Arrow 13"/>
           <p:cNvSpPr/>
           <p:nvPr/>
         </p:nvSpPr>
         <p:spPr>
           <a:xfrm>
-            <a:off x="7104888" y="2286000"/>
-            <a:ext cx="1508760" cy="1188720"/>
-          </a:xfrm>
-          <a:prstGeom prst="roundRect">
+            <a:off x="8613648" y="2743200"/>
+            <a:ext cx="164592" cy="274320"/>
+          </a:xfrm>
+          <a:prstGeom prst="rightArrow">
             <a:avLst/>
           </a:prstGeom>
           <a:solidFill>
-            <a:srgbClr val="1C7293"/>
+            <a:srgbClr val="555F6D"/>
           </a:solidFill>
           <a:ln>
             <a:noFill/>
@@ -12500,38 +11864,29 @@
           </a:fontRef>
         </p:style>
         <p:txBody>
-          <a:bodyPr rtlCol="0" anchor="ctr" lIns="45720" rIns="45720" wrap="square"/>
+          <a:bodyPr rtlCol="0" anchor="ctr"/>
           <a:lstStyle/>
           <a:p>
             <a:pPr algn="ctr"/>
-            <a:r>
-              <a:rPr sz="1200" b="1">
-                <a:solidFill>
-                  <a:srgbClr val="F2F4F8"/>
-                </a:solidFill>
-                <a:latin typeface="Calibri"/>
-              </a:rPr>
-              <a:t>LayerNorm</a:t>
-            </a:r>
-          </a:p>
-        </p:txBody>
-      </p:sp>
-      <p:sp>
-        <p:nvSpPr>
-          <p:cNvPr id="15" name="Right Arrow 14"/>
+          </a:p>
+        </p:txBody>
+      </p:sp>
+      <p:sp>
+        <p:nvSpPr>
+          <p:cNvPr id="15" name="Rounded Rectangle 14"/>
           <p:cNvSpPr/>
           <p:nvPr/>
         </p:nvSpPr>
         <p:spPr>
           <a:xfrm>
-            <a:off x="8613648" y="2743200"/>
-            <a:ext cx="164592" cy="274320"/>
-          </a:xfrm>
-          <a:prstGeom prst="rightArrow">
+            <a:off x="8778240" y="2286000"/>
+            <a:ext cx="1508760" cy="1188720"/>
+          </a:xfrm>
+          <a:prstGeom prst="roundRect">
             <a:avLst/>
           </a:prstGeom>
           <a:solidFill>
-            <a:srgbClr val="555F6D"/>
+            <a:srgbClr val="1C7293"/>
           </a:solidFill>
           <a:ln>
             <a:noFill/>
@@ -12552,29 +11907,50 @@
           </a:fontRef>
         </p:style>
         <p:txBody>
-          <a:bodyPr rtlCol="0" anchor="ctr"/>
+          <a:bodyPr rtlCol="0" anchor="ctr" lIns="45720" rIns="45720" wrap="square"/>
           <a:lstStyle/>
           <a:p>
             <a:pPr algn="ctr"/>
-          </a:p>
-        </p:txBody>
-      </p:sp>
-      <p:sp>
-        <p:nvSpPr>
-          <p:cNvPr id="16" name="Rounded Rectangle 15"/>
+            <a:r>
+              <a:rPr sz="1200" b="1">
+                <a:solidFill>
+                  <a:srgbClr val="F2F4F8"/>
+                </a:solidFill>
+                <a:latin typeface="Calibri"/>
+              </a:rPr>
+              <a:t>Linear(32,1)</a:t>
+            </a:r>
+          </a:p>
+          <a:p>
+            <a:pPr algn="ctr"/>
+            <a:r>
+              <a:rPr sz="1200" b="1">
+                <a:solidFill>
+                  <a:srgbClr val="F2F4F8"/>
+                </a:solidFill>
+                <a:latin typeface="Calibri"/>
+              </a:rPr>
+              <a:t>out head</a:t>
+            </a:r>
+          </a:p>
+        </p:txBody>
+      </p:sp>
+      <p:sp>
+        <p:nvSpPr>
+          <p:cNvPr id="16" name="Right Arrow 15"/>
           <p:cNvSpPr/>
           <p:nvPr/>
         </p:nvSpPr>
         <p:spPr>
           <a:xfrm>
-            <a:off x="8778240" y="2286000"/>
-            <a:ext cx="1508760" cy="1188720"/>
-          </a:xfrm>
-          <a:prstGeom prst="roundRect">
+            <a:off x="10287000" y="2743200"/>
+            <a:ext cx="164592" cy="274320"/>
+          </a:xfrm>
+          <a:prstGeom prst="rightArrow">
             <a:avLst/>
           </a:prstGeom>
           <a:solidFill>
-            <a:srgbClr val="1C7293"/>
+            <a:srgbClr val="555F6D"/>
           </a:solidFill>
           <a:ln>
             <a:noFill/>
@@ -12595,50 +11971,29 @@
           </a:fontRef>
         </p:style>
         <p:txBody>
-          <a:bodyPr rtlCol="0" anchor="ctr" lIns="45720" rIns="45720" wrap="square"/>
+          <a:bodyPr rtlCol="0" anchor="ctr"/>
           <a:lstStyle/>
           <a:p>
             <a:pPr algn="ctr"/>
-            <a:r>
-              <a:rPr sz="1200" b="1">
-                <a:solidFill>
-                  <a:srgbClr val="F2F4F8"/>
-                </a:solidFill>
-                <a:latin typeface="Calibri"/>
-              </a:rPr>
-              <a:t>Linear(32,1)</a:t>
-            </a:r>
-          </a:p>
-          <a:p>
-            <a:pPr algn="ctr"/>
-            <a:r>
-              <a:rPr sz="1200" b="1">
-                <a:solidFill>
-                  <a:srgbClr val="F2F4F8"/>
-                </a:solidFill>
-                <a:latin typeface="Calibri"/>
-              </a:rPr>
-              <a:t>out head</a:t>
-            </a:r>
-          </a:p>
-        </p:txBody>
-      </p:sp>
-      <p:sp>
-        <p:nvSpPr>
-          <p:cNvPr id="17" name="Right Arrow 16"/>
+          </a:p>
+        </p:txBody>
+      </p:sp>
+      <p:sp>
+        <p:nvSpPr>
+          <p:cNvPr id="17" name="Rounded Rectangle 16"/>
           <p:cNvSpPr/>
           <p:nvPr/>
         </p:nvSpPr>
         <p:spPr>
           <a:xfrm>
-            <a:off x="10287000" y="2743200"/>
-            <a:ext cx="164592" cy="274320"/>
-          </a:xfrm>
-          <a:prstGeom prst="rightArrow">
+            <a:off x="10451592" y="2286000"/>
+            <a:ext cx="1508760" cy="1188720"/>
+          </a:xfrm>
+          <a:prstGeom prst="roundRect">
             <a:avLst/>
           </a:prstGeom>
           <a:solidFill>
-            <a:srgbClr val="555F6D"/>
+            <a:srgbClr val="F5A623"/>
           </a:solidFill>
           <a:ln>
             <a:noFill/>
@@ -12659,51 +12014,20 @@
           </a:fontRef>
         </p:style>
         <p:txBody>
-          <a:bodyPr rtlCol="0" anchor="ctr"/>
+          <a:bodyPr rtlCol="0" anchor="ctr" lIns="45720" rIns="45720" wrap="square"/>
           <a:lstStyle/>
           <a:p>
             <a:pPr algn="ctr"/>
-          </a:p>
-        </p:txBody>
-      </p:sp>
-      <p:sp>
-        <p:nvSpPr>
-          <p:cNvPr id="18" name="Rounded Rectangle 17"/>
-          <p:cNvSpPr/>
-          <p:nvPr/>
-        </p:nvSpPr>
-        <p:spPr>
-          <a:xfrm>
-            <a:off x="10451592" y="2286000"/>
-            <a:ext cx="1508760" cy="1188720"/>
-          </a:xfrm>
-          <a:prstGeom prst="roundRect">
-            <a:avLst/>
-          </a:prstGeom>
-          <a:solidFill>
-            <a:srgbClr val="F5A623"/>
-          </a:solidFill>
-          <a:ln>
-            <a:noFill/>
-          </a:ln>
-        </p:spPr>
-        <p:style>
-          <a:lnRef idx="1">
-            <a:schemeClr val="accent1"/>
-          </a:lnRef>
-          <a:fillRef idx="3">
-            <a:schemeClr val="accent1"/>
-          </a:fillRef>
-          <a:effectRef idx="2">
-            <a:schemeClr val="accent1"/>
-          </a:effectRef>
-          <a:fontRef idx="minor">
-            <a:schemeClr val="lt1"/>
-          </a:fontRef>
-        </p:style>
-        <p:txBody>
-          <a:bodyPr rtlCol="0" anchor="ctr" lIns="45720" rIns="45720" wrap="square"/>
-          <a:lstStyle/>
+            <a:r>
+              <a:rPr sz="1200" b="1">
+                <a:solidFill>
+                  <a:srgbClr val="F2F4F8"/>
+                </a:solidFill>
+                <a:latin typeface="Calibri"/>
+              </a:rPr>
+              <a:t>Next</a:t>
+            </a:r>
+          </a:p>
           <a:p>
             <a:pPr algn="ctr"/>
             <a:r>
@@ -12713,18 +12037,6 @@
                 </a:solidFill>
                 <a:latin typeface="Calibri"/>
               </a:rPr>
-              <a:t>Next</a:t>
-            </a:r>
-          </a:p>
-          <a:p>
-            <a:pPr algn="ctr"/>
-            <a:r>
-              <a:rPr sz="1200" b="1">
-                <a:solidFill>
-                  <a:srgbClr val="F2F4F8"/>
-                </a:solidFill>
-                <a:latin typeface="Calibri"/>
-              </a:rPr>
               <a:t>sample</a:t>
             </a:r>
           </a:p>
@@ -12732,7 +12044,7 @@
       </p:sp>
       <p:sp>
         <p:nvSpPr>
-          <p:cNvPr id="19" name="TextBox 18"/>
+          <p:cNvPr id="18" name="TextBox 17"/>
           <p:cNvSpPr txBox="1"/>
           <p:nvPr/>
         </p:nvSpPr>
@@ -12767,7 +12079,7 @@
       </p:sp>
       <p:sp>
         <p:nvSpPr>
-          <p:cNvPr id="20" name="TextBox 19"/>
+          <p:cNvPr id="19" name="TextBox 18"/>
           <p:cNvSpPr txBox="1"/>
           <p:nvPr/>
         </p:nvSpPr>
@@ -12956,52 +12268,9 @@
           </a:p>
         </p:txBody>
       </p:sp>
-      <p:sp>
-        <p:nvSpPr>
-          <p:cNvPr id="5" name="Rectangle 4"/>
-          <p:cNvSpPr/>
-          <p:nvPr/>
-        </p:nvSpPr>
-        <p:spPr>
-          <a:xfrm>
-            <a:off x="548640" y="1508760"/>
-            <a:ext cx="109728" cy="548640"/>
-          </a:xfrm>
-          <a:prstGeom prst="rect">
-            <a:avLst/>
-          </a:prstGeom>
-          <a:solidFill>
-            <a:srgbClr val="F5A623"/>
-          </a:solidFill>
-          <a:ln>
-            <a:noFill/>
-          </a:ln>
-        </p:spPr>
-        <p:style>
-          <a:lnRef idx="1">
-            <a:schemeClr val="accent1"/>
-          </a:lnRef>
-          <a:fillRef idx="3">
-            <a:schemeClr val="accent1"/>
-          </a:fillRef>
-          <a:effectRef idx="2">
-            <a:schemeClr val="accent1"/>
-          </a:effectRef>
-          <a:fontRef idx="minor">
-            <a:schemeClr val="lt1"/>
-          </a:fontRef>
-        </p:style>
-        <p:txBody>
-          <a:bodyPr rtlCol="0" anchor="ctr"/>
-          <a:lstStyle/>
-          <a:p>
-            <a:pPr algn="ctr"/>
-          </a:p>
-        </p:txBody>
-      </p:sp>
       <p:graphicFrame>
         <p:nvGraphicFramePr>
-          <p:cNvPr id="6" name="Table 5"/>
+          <p:cNvPr id="5" name="Table 4"/>
           <p:cNvGraphicFramePr>
             <a:graphicFrameLocks noGrp="1"/>
           </p:cNvGraphicFramePr>
@@ -13478,7 +12747,7 @@
       </p:graphicFrame>
       <p:sp>
         <p:nvSpPr>
-          <p:cNvPr id="7" name="Rounded Rectangle 6"/>
+          <p:cNvPr id="6" name="Rounded Rectangle 5"/>
           <p:cNvSpPr/>
           <p:nvPr/>
         </p:nvSpPr>
@@ -13523,7 +12792,7 @@
       </p:sp>
       <p:sp>
         <p:nvSpPr>
-          <p:cNvPr id="8" name="TextBox 7"/>
+          <p:cNvPr id="7" name="TextBox 6"/>
           <p:cNvSpPr txBox="1"/>
           <p:nvPr/>
         </p:nvSpPr>
@@ -13558,7 +12827,7 @@
       </p:sp>
       <p:sp>
         <p:nvSpPr>
-          <p:cNvPr id="9" name="TextBox 8"/>
+          <p:cNvPr id="8" name="TextBox 7"/>
           <p:cNvSpPr txBox="1"/>
           <p:nvPr/>
         </p:nvSpPr>
@@ -13723,52 +12992,9 @@
           </a:p>
         </p:txBody>
       </p:sp>
-      <p:sp>
-        <p:nvSpPr>
-          <p:cNvPr id="5" name="Rectangle 4"/>
-          <p:cNvSpPr/>
-          <p:nvPr/>
-        </p:nvSpPr>
-        <p:spPr>
-          <a:xfrm>
-            <a:off x="548640" y="1508760"/>
-            <a:ext cx="109728" cy="548640"/>
-          </a:xfrm>
-          <a:prstGeom prst="rect">
-            <a:avLst/>
-          </a:prstGeom>
-          <a:solidFill>
-            <a:srgbClr val="F5A623"/>
-          </a:solidFill>
-          <a:ln>
-            <a:noFill/>
-          </a:ln>
-        </p:spPr>
-        <p:style>
-          <a:lnRef idx="1">
-            <a:schemeClr val="accent1"/>
-          </a:lnRef>
-          <a:fillRef idx="3">
-            <a:schemeClr val="accent1"/>
-          </a:fillRef>
-          <a:effectRef idx="2">
-            <a:schemeClr val="accent1"/>
-          </a:effectRef>
-          <a:fontRef idx="minor">
-            <a:schemeClr val="lt1"/>
-          </a:fontRef>
-        </p:style>
-        <p:txBody>
-          <a:bodyPr rtlCol="0" anchor="ctr"/>
-          <a:lstStyle/>
-          <a:p>
-            <a:pPr algn="ctr"/>
-          </a:p>
-        </p:txBody>
-      </p:sp>
       <p:graphicFrame>
         <p:nvGraphicFramePr>
-          <p:cNvPr id="6" name="Table 5"/>
+          <p:cNvPr id="5" name="Table 4"/>
           <p:cNvGraphicFramePr>
             <a:graphicFrameLocks noGrp="1"/>
           </p:cNvGraphicFramePr>
@@ -14203,7 +13429,7 @@
       </p:graphicFrame>
       <p:sp>
         <p:nvSpPr>
-          <p:cNvPr id="7" name="TextBox 6"/>
+          <p:cNvPr id="6" name="TextBox 5"/>
           <p:cNvSpPr txBox="1"/>
           <p:nvPr/>
         </p:nvSpPr>
@@ -14382,50 +13608,7 @@
       </p:sp>
       <p:sp>
         <p:nvSpPr>
-          <p:cNvPr id="5" name="Rectangle 4"/>
-          <p:cNvSpPr/>
-          <p:nvPr/>
-        </p:nvSpPr>
-        <p:spPr>
-          <a:xfrm>
-            <a:off x="548640" y="1508760"/>
-            <a:ext cx="109728" cy="548640"/>
-          </a:xfrm>
-          <a:prstGeom prst="rect">
-            <a:avLst/>
-          </a:prstGeom>
-          <a:solidFill>
-            <a:srgbClr val="F5A623"/>
-          </a:solidFill>
-          <a:ln>
-            <a:noFill/>
-          </a:ln>
-        </p:spPr>
-        <p:style>
-          <a:lnRef idx="1">
-            <a:schemeClr val="accent1"/>
-          </a:lnRef>
-          <a:fillRef idx="3">
-            <a:schemeClr val="accent1"/>
-          </a:fillRef>
-          <a:effectRef idx="2">
-            <a:schemeClr val="accent1"/>
-          </a:effectRef>
-          <a:fontRef idx="minor">
-            <a:schemeClr val="lt1"/>
-          </a:fontRef>
-        </p:style>
-        <p:txBody>
-          <a:bodyPr rtlCol="0" anchor="ctr"/>
-          <a:lstStyle/>
-          <a:p>
-            <a:pPr algn="ctr"/>
-          </a:p>
-        </p:txBody>
-      </p:sp>
-      <p:sp>
-        <p:nvSpPr>
-          <p:cNvPr id="6" name="TextBox 5"/>
+          <p:cNvPr id="5" name="TextBox 4"/>
           <p:cNvSpPr txBox="1"/>
           <p:nvPr/>
         </p:nvSpPr>
@@ -14460,7 +13643,7 @@
       </p:sp>
       <p:sp>
         <p:nvSpPr>
-          <p:cNvPr id="7" name="TextBox 6"/>
+          <p:cNvPr id="6" name="TextBox 5"/>
           <p:cNvSpPr txBox="1"/>
           <p:nvPr/>
         </p:nvSpPr>
@@ -14495,7 +13678,7 @@
       </p:sp>
       <p:sp>
         <p:nvSpPr>
-          <p:cNvPr id="8" name="TextBox 7"/>
+          <p:cNvPr id="7" name="TextBox 6"/>
           <p:cNvSpPr txBox="1"/>
           <p:nvPr/>
         </p:nvSpPr>
@@ -14554,7 +13737,7 @@
       </p:sp>
       <p:sp>
         <p:nvSpPr>
-          <p:cNvPr id="9" name="TextBox 8"/>
+          <p:cNvPr id="8" name="TextBox 7"/>
           <p:cNvSpPr txBox="1"/>
           <p:nvPr/>
         </p:nvSpPr>
@@ -14589,7 +13772,7 @@
       </p:sp>
       <p:sp>
         <p:nvSpPr>
-          <p:cNvPr id="10" name="TextBox 9"/>
+          <p:cNvPr id="9" name="TextBox 8"/>
           <p:cNvSpPr txBox="1"/>
           <p:nvPr/>
         </p:nvSpPr>
@@ -14780,50 +13963,7 @@
       </p:sp>
       <p:sp>
         <p:nvSpPr>
-          <p:cNvPr id="5" name="Rectangle 4"/>
-          <p:cNvSpPr/>
-          <p:nvPr/>
-        </p:nvSpPr>
-        <p:spPr>
-          <a:xfrm>
-            <a:off x="548640" y="1508760"/>
-            <a:ext cx="109728" cy="548640"/>
-          </a:xfrm>
-          <a:prstGeom prst="rect">
-            <a:avLst/>
-          </a:prstGeom>
-          <a:solidFill>
-            <a:srgbClr val="F5A623"/>
-          </a:solidFill>
-          <a:ln>
-            <a:noFill/>
-          </a:ln>
-        </p:spPr>
-        <p:style>
-          <a:lnRef idx="1">
-            <a:schemeClr val="accent1"/>
-          </a:lnRef>
-          <a:fillRef idx="3">
-            <a:schemeClr val="accent1"/>
-          </a:fillRef>
-          <a:effectRef idx="2">
-            <a:schemeClr val="accent1"/>
-          </a:effectRef>
-          <a:fontRef idx="minor">
-            <a:schemeClr val="lt1"/>
-          </a:fontRef>
-        </p:style>
-        <p:txBody>
-          <a:bodyPr rtlCol="0" anchor="ctr"/>
-          <a:lstStyle/>
-          <a:p>
-            <a:pPr algn="ctr"/>
-          </a:p>
-        </p:txBody>
-      </p:sp>
-      <p:sp>
-        <p:nvSpPr>
-          <p:cNvPr id="6" name="TextBox 5"/>
+          <p:cNvPr id="5" name="TextBox 4"/>
           <p:cNvSpPr txBox="1"/>
           <p:nvPr/>
         </p:nvSpPr>
@@ -14858,7 +13998,7 @@
       </p:sp>
       <p:graphicFrame>
         <p:nvGraphicFramePr>
-          <p:cNvPr id="7" name="Table 6"/>
+          <p:cNvPr id="6" name="Table 5"/>
           <p:cNvGraphicFramePr>
             <a:graphicFrameLocks noGrp="1"/>
           </p:cNvGraphicFramePr>
@@ -15426,7 +14566,7 @@
       </p:graphicFrame>
       <p:sp>
         <p:nvSpPr>
-          <p:cNvPr id="8" name="TextBox 7"/>
+          <p:cNvPr id="7" name="TextBox 6"/>
           <p:cNvSpPr txBox="1"/>
           <p:nvPr/>
         </p:nvSpPr>

</xml_diff>